<commit_message>
docs: viewer RBAC + audit trail, live-zone checklist auto-tick, employee room inspection
- README: new feature bullets (per-room roles owner/member/viewer + audit
  trail; live-zone checklist auto-tick with N/A; audited read-only employee
  inspection), synced-state (liveZone, glide_room_audit), roles in invite flow,
  Audit tab, and three security-notes bullets.
- docs/architecture: cf-api getZoneSslMode/getZoneManagedWafDeployed readers.
- docs/onboarding-and-migration: autoDoneSteps {done,na}, live-zone auto-ticking,
  LiveZoneFacts + OnboardingStep.na state reference.
- docs/tools: find_zone/list_dns_records live-zone capture; inviteTeammate role
  arg, setMemberRole, getAuditLog, RBAC + audit callouts.
- docs/security: owner/member/viewer ACL + four threat-model rows.
- docs/README: refreshed index descriptions.
- Glide.pptx: roadmap #4 (Governance) marked SHIPPED with updated description.
- GLIDE_FIX_PROGRESS: Follow-up 15 log.
</commit_message>
<xml_diff>
--- a/Glide.pptx
+++ b/Glide.pptx
@@ -7737,6 +7737,17 @@
               </a:rPr>
               <a:t>Governance</a:t>
             </a:r>
+            <a:r>
+              <a:rPr lang="en-US" sz="1450" b="1" dirty="0">
+                <a:solidFill>
+                  <a:srgbClr val="4ADE80"/>
+                </a:solidFill>
+                <a:latin typeface="Arial" pitchFamily="34" charset="0"/>
+                <a:ea typeface="Arial" pitchFamily="34" charset="-122"/>
+                <a:cs typeface="Arial" pitchFamily="34" charset="-120"/>
+              </a:rPr>
+              <a:t xml:space="preserve">   ·   SHIPPED</a:t>
+            </a:r>
             <a:endParaRPr lang="en-US" sz="1450" dirty="0"/>
           </a:p>
         </p:txBody>
@@ -7774,7 +7785,7 @@
                 <a:ea typeface="Arial" pitchFamily="34" charset="-122"/>
                 <a:cs typeface="Arial" pitchFamily="34" charset="-120"/>
               </a:rPr>
-              <a:t>Per-room auth / RBAC and exportable audit trails of who queued and applied what.</a:t>
+              <a:t>Per-room roles (owner / member / viewer) plus an exportable, owner-only audit trail.</a:t>
             </a:r>
             <a:endParaRPr lang="en-US" sz="1080" dirty="0"/>
           </a:p>

</xml_diff>

<commit_message>
docs(deck): move Governance out of the roadmap into Capabilities
Roadmap slide now shows four evenly spaced phases (Governance row
removed). The Capabilities slide's 'Export & collaborate' card is
renamed 'Collaborate & govern' and covers role-based rooms (owner/
member/viewer), owner-only delete, the exportable audit trail, and the
all-rooms admin view.
</commit_message>
<xml_diff>
--- a/Glide.pptx
+++ b/Glide.pptx
@@ -6730,7 +6730,7 @@
                 <a:ea typeface="Arial" pitchFamily="34" charset="-122"/>
                 <a:cs typeface="Arial" pitchFamily="34" charset="-120"/>
               </a:rPr>
-              <a:t>Export &amp; collaborate</a:t>
+              <a:t>Collaborate &amp; govern</a:t>
             </a:r>
             <a:endParaRPr lang="en-US" sz="1550" dirty="0"/>
           </a:p>
@@ -6772,7 +6772,7 @@
                 <a:ea typeface="Arial" pitchFamily="34" charset="-122"/>
                 <a:cs typeface="Arial" pitchFamily="34" charset="-120"/>
               </a:rPr>
-              <a:t>IaC and CSV exports; multi-user rooms with invites, naming, owner-only delete, and an employee all-rooms admin view.</a:t>
+              <a:t>Role-based rooms (owner / member / viewer) with invites, owner-only delete, an exportable audit trail, and an all-rooms admin view.</a:t>
             </a:r>
             <a:endParaRPr lang="en-US" sz="1150" dirty="0"/>
           </a:p>
@@ -6837,7 +6837,7 @@
                 <a:ea typeface="Courier New" pitchFamily="34" charset="-122"/>
                 <a:cs typeface="Courier New" pitchFamily="34" charset="-120"/>
               </a:rPr>
-              <a:t>generate_migration_terraform · export_migration_csv · setRoomName · destroyRoom</a:t>
+              <a:t>setMemberRole · getAuditLog · setRoomName · destroyRoom · export_migration_csv</a:t>
             </a:r>
             <a:endParaRPr lang="en-US" sz="880" dirty="0"/>
           </a:p>
@@ -7290,7 +7290,7 @@
         </p:nvSpPr>
         <p:spPr>
           <a:xfrm>
-            <a:off x="640080" y="2752344"/>
+            <a:off x="640080" y="2953512"/>
             <a:ext cx="8138160" cy="749808"/>
           </a:xfrm>
           <a:prstGeom prst="roundRect">
@@ -7317,7 +7317,7 @@
         </p:nvSpPr>
         <p:spPr>
           <a:xfrm>
-            <a:off x="804672" y="2907792"/>
+            <a:off x="804672" y="3108960"/>
             <a:ext cx="438912" cy="438912"/>
           </a:xfrm>
           <a:prstGeom prst="roundRect">
@@ -7339,7 +7339,7 @@
         </p:nvSpPr>
         <p:spPr>
           <a:xfrm>
-            <a:off x="804672" y="2907792"/>
+            <a:off x="804672" y="3108960"/>
             <a:ext cx="438912" cy="438912"/>
           </a:xfrm>
           <a:prstGeom prst="rect">
@@ -7378,7 +7378,7 @@
         </p:nvSpPr>
         <p:spPr>
           <a:xfrm>
-            <a:off x="1417320" y="2843784"/>
+            <a:off x="1417320" y="3044952"/>
             <a:ext cx="7223760" cy="310896"/>
           </a:xfrm>
           <a:prstGeom prst="rect">
@@ -7417,7 +7417,7 @@
         </p:nvSpPr>
         <p:spPr>
           <a:xfrm>
-            <a:off x="1417320" y="3136392"/>
+            <a:off x="1417320" y="3337560"/>
             <a:ext cx="7223760" cy="310896"/>
           </a:xfrm>
           <a:prstGeom prst="rect">
@@ -7456,7 +7456,7 @@
         </p:nvSpPr>
         <p:spPr>
           <a:xfrm>
-            <a:off x="640080" y="3630168"/>
+            <a:off x="640080" y="4032504"/>
             <a:ext cx="8138160" cy="749808"/>
           </a:xfrm>
           <a:prstGeom prst="roundRect">
@@ -7483,7 +7483,7 @@
         </p:nvSpPr>
         <p:spPr>
           <a:xfrm>
-            <a:off x="804672" y="3785616"/>
+            <a:off x="804672" y="4187952"/>
             <a:ext cx="438912" cy="438912"/>
           </a:xfrm>
           <a:prstGeom prst="roundRect">
@@ -7505,7 +7505,7 @@
         </p:nvSpPr>
         <p:spPr>
           <a:xfrm>
-            <a:off x="804672" y="3785616"/>
+            <a:off x="804672" y="4187952"/>
             <a:ext cx="438912" cy="438912"/>
           </a:xfrm>
           <a:prstGeom prst="rect">
@@ -7544,7 +7544,7 @@
         </p:nvSpPr>
         <p:spPr>
           <a:xfrm>
-            <a:off x="1417320" y="3721608"/>
+            <a:off x="1417320" y="4123944"/>
             <a:ext cx="7223760" cy="310896"/>
           </a:xfrm>
           <a:prstGeom prst="rect">
@@ -7583,7 +7583,7 @@
         </p:nvSpPr>
         <p:spPr>
           <a:xfrm>
-            <a:off x="1417320" y="4014216"/>
+            <a:off x="1417320" y="4416552"/>
             <a:ext cx="7223760" cy="310896"/>
           </a:xfrm>
           <a:prstGeom prst="rect">
@@ -7622,7 +7622,7 @@
         </p:nvSpPr>
         <p:spPr>
           <a:xfrm>
-            <a:off x="640080" y="4507992"/>
+            <a:off x="640080" y="5111496"/>
             <a:ext cx="8138160" cy="749808"/>
           </a:xfrm>
           <a:prstGeom prst="roundRect">
@@ -7649,7 +7649,7 @@
         </p:nvSpPr>
         <p:spPr>
           <a:xfrm>
-            <a:off x="804672" y="4663440"/>
+            <a:off x="804672" y="5266944"/>
             <a:ext cx="438912" cy="438912"/>
           </a:xfrm>
           <a:prstGeom prst="roundRect">
@@ -7671,7 +7671,7 @@
         </p:nvSpPr>
         <p:spPr>
           <a:xfrm>
-            <a:off x="804672" y="4663440"/>
+            <a:off x="804672" y="5266944"/>
             <a:ext cx="438912" cy="438912"/>
           </a:xfrm>
           <a:prstGeom prst="rect">
@@ -7710,7 +7710,7 @@
         </p:nvSpPr>
         <p:spPr>
           <a:xfrm>
-            <a:off x="1417320" y="4599432"/>
+            <a:off x="1417320" y="5202936"/>
             <a:ext cx="7223760" cy="310896"/>
           </a:xfrm>
           <a:prstGeom prst="rect">
@@ -7735,18 +7735,7 @@
                 <a:ea typeface="Arial" pitchFamily="34" charset="-122"/>
                 <a:cs typeface="Arial" pitchFamily="34" charset="-120"/>
               </a:rPr>
-              <a:t>Governance</a:t>
-            </a:r>
-            <a:r>
-              <a:rPr lang="en-US" sz="1450" b="1" dirty="0">
-                <a:solidFill>
-                  <a:srgbClr val="4ADE80"/>
-                </a:solidFill>
-                <a:latin typeface="Arial" pitchFamily="34" charset="0"/>
-                <a:ea typeface="Arial" pitchFamily="34" charset="-122"/>
-                <a:cs typeface="Arial" pitchFamily="34" charset="-120"/>
-              </a:rPr>
-              <a:t xml:space="preserve">   ·   SHIPPED</a:t>
+              <a:t>Proactive posture</a:t>
             </a:r>
             <a:endParaRPr lang="en-US" sz="1450" dirty="0"/>
           </a:p>
@@ -7760,173 +7749,7 @@
         </p:nvSpPr>
         <p:spPr>
           <a:xfrm>
-            <a:off x="1417320" y="4892040"/>
-            <a:ext cx="7223760" cy="310896"/>
-          </a:xfrm>
-          <a:prstGeom prst="rect">
-            <a:avLst/>
-          </a:prstGeom>
-          <a:noFill/>
-          <a:ln/>
-        </p:spPr>
-        <p:txBody>
-          <a:bodyPr wrap="square" lIns="0" tIns="0" rIns="0" bIns="0" rtlCol="0" anchor="ctr"/>
-          <a:lstStyle/>
-          <a:p>
-            <a:pPr algn="l" indent="0" marL="0">
-              <a:buNone/>
-            </a:pPr>
-            <a:r>
-              <a:rPr lang="en-US" sz="1080" dirty="0">
-                <a:solidFill>
-                  <a:srgbClr val="C7D2E4"/>
-                </a:solidFill>
-                <a:latin typeface="Arial" pitchFamily="34" charset="0"/>
-                <a:ea typeface="Arial" pitchFamily="34" charset="-122"/>
-                <a:cs typeface="Arial" pitchFamily="34" charset="-120"/>
-              </a:rPr>
-              <a:t>Per-room roles (owner / member / viewer) plus an exportable, owner-only audit trail.</a:t>
-            </a:r>
-            <a:endParaRPr lang="en-US" sz="1080" dirty="0"/>
-          </a:p>
-        </p:txBody>
-      </p:sp>
-      <p:sp>
-        <p:nvSpPr>
-          <p:cNvPr id="26" name="Shape 24"/>
-          <p:cNvSpPr/>
-          <p:nvPr/>
-        </p:nvSpPr>
-        <p:spPr>
-          <a:xfrm>
-            <a:off x="640080" y="5385816"/>
-            <a:ext cx="8138160" cy="749808"/>
-          </a:xfrm>
-          <a:prstGeom prst="roundRect">
-            <a:avLst>
-              <a:gd name="adj" fmla="val 9756"/>
-            </a:avLst>
-          </a:prstGeom>
-          <a:solidFill>
-            <a:srgbClr val="111A2E"/>
-          </a:solidFill>
-          <a:ln w="12700">
-            <a:solidFill>
-              <a:srgbClr val="1B2740"/>
-            </a:solidFill>
-            <a:prstDash val="solid"/>
-          </a:ln>
-        </p:spPr>
-      </p:sp>
-      <p:sp>
-        <p:nvSpPr>
-          <p:cNvPr id="27" name="Shape 25"/>
-          <p:cNvSpPr/>
-          <p:nvPr/>
-        </p:nvSpPr>
-        <p:spPr>
-          <a:xfrm>
-            <a:off x="804672" y="5541264"/>
-            <a:ext cx="438912" cy="438912"/>
-          </a:xfrm>
-          <a:prstGeom prst="roundRect">
-            <a:avLst>
-              <a:gd name="adj" fmla="val 12500"/>
-            </a:avLst>
-          </a:prstGeom>
-          <a:solidFill>
-            <a:srgbClr val="F97316"/>
-          </a:solidFill>
-          <a:ln/>
-        </p:spPr>
-      </p:sp>
-      <p:sp>
-        <p:nvSpPr>
-          <p:cNvPr id="28" name="Text 26"/>
-          <p:cNvSpPr/>
-          <p:nvPr/>
-        </p:nvSpPr>
-        <p:spPr>
-          <a:xfrm>
-            <a:off x="804672" y="5541264"/>
-            <a:ext cx="438912" cy="438912"/>
-          </a:xfrm>
-          <a:prstGeom prst="rect">
-            <a:avLst/>
-          </a:prstGeom>
-          <a:noFill/>
-          <a:ln/>
-        </p:spPr>
-        <p:txBody>
-          <a:bodyPr wrap="square" lIns="0" tIns="0" rIns="0" bIns="0" rtlCol="0" anchor="ctr"/>
-          <a:lstStyle/>
-          <a:p>
-            <a:pPr algn="ctr" indent="0" marL="0">
-              <a:buNone/>
-            </a:pPr>
-            <a:r>
-              <a:rPr lang="en-US" sz="1700" b="1" dirty="0">
-                <a:solidFill>
-                  <a:srgbClr val="070B16"/>
-                </a:solidFill>
-                <a:latin typeface="Arial" pitchFamily="34" charset="0"/>
-                <a:ea typeface="Arial" pitchFamily="34" charset="-122"/>
-                <a:cs typeface="Arial" pitchFamily="34" charset="-120"/>
-              </a:rPr>
-              <a:t>5</a:t>
-            </a:r>
-            <a:endParaRPr lang="en-US" sz="1700" dirty="0"/>
-          </a:p>
-        </p:txBody>
-      </p:sp>
-      <p:sp>
-        <p:nvSpPr>
-          <p:cNvPr id="29" name="Text 27"/>
-          <p:cNvSpPr/>
-          <p:nvPr/>
-        </p:nvSpPr>
-        <p:spPr>
-          <a:xfrm>
-            <a:off x="1417320" y="5477256"/>
-            <a:ext cx="7223760" cy="310896"/>
-          </a:xfrm>
-          <a:prstGeom prst="rect">
-            <a:avLst/>
-          </a:prstGeom>
-          <a:noFill/>
-          <a:ln/>
-        </p:spPr>
-        <p:txBody>
-          <a:bodyPr wrap="square" lIns="0" tIns="0" rIns="0" bIns="0" rtlCol="0" anchor="ctr"/>
-          <a:lstStyle/>
-          <a:p>
-            <a:pPr algn="l" indent="0" marL="0">
-              <a:buNone/>
-            </a:pPr>
-            <a:r>
-              <a:rPr lang="en-US" sz="1450" b="1" dirty="0">
-                <a:solidFill>
-                  <a:srgbClr val="FFFFFF"/>
-                </a:solidFill>
-                <a:latin typeface="Arial" pitchFamily="34" charset="0"/>
-                <a:ea typeface="Arial" pitchFamily="34" charset="-122"/>
-                <a:cs typeface="Arial" pitchFamily="34" charset="-120"/>
-              </a:rPr>
-              <a:t>Proactive posture</a:t>
-            </a:r>
-            <a:endParaRPr lang="en-US" sz="1450" dirty="0"/>
-          </a:p>
-        </p:txBody>
-      </p:sp>
-      <p:sp>
-        <p:nvSpPr>
-          <p:cNvPr id="30" name="Text 28"/>
-          <p:cNvSpPr/>
-          <p:nvPr/>
-        </p:nvSpPr>
-        <p:spPr>
-          <a:xfrm>
-            <a:off x="1417320" y="5769864"/>
+            <a:off x="1417320" y="5495544"/>
             <a:ext cx="7223760" cy="310896"/>
           </a:xfrm>
           <a:prstGeom prst="rect">

</xml_diff>

<commit_message>
docs+deck: document governance suite & verify; add ROI + Governance slides
- Docs: drop stale "validation disabled" claims across README and docs/*;
  document the governance & change-safety suite (posture scorecard, drift
  watch, blast radius, auto-rollback, scheduled Apply, four-eyes, webhook +
  in-app notifications) and the re-enabled read-only post-migration Verify
  presence check.
- Deck: add Governance & Control and Return-on-Investment slides, correct the
  tool count (26 -> 24), sharpen the title tagline, refresh roadmap items, and
  renumber footers to /9.
</commit_message>
<xml_diff>
--- a/Glide.pptx
+++ b/Glide.pptx
@@ -11,6 +11,8 @@
     <p:sldId id="259" r:id="rId5"/>
     <p:sldId id="260" r:id="rId6"/>
     <p:sldId id="262" r:id="rId13"/>
+    <p:sldId id="263" r:id="rId14"/>
+    <p:sldId id="264" r:id="rId15"/>
     <p:sldId id="261" r:id="rId7"/>
   </p:sldIdLst>
   <p:notesMasterIdLst>
@@ -1497,18 +1499,52 @@
         </p:nvSpPr>
         <p:spPr>
           <a:xfrm>
-            <a:off x="713232" y="3794760"/>
-            <a:ext cx="9692640" cy="914400"/>
-          </a:xfrm>
-          <a:prstGeom prst="rect">
-            <a:avLst/>
-          </a:prstGeom>
-          <a:noFill/>
-          <a:ln/>
-        </p:spPr>
-        <p:txBody>
-          <a:bodyPr wrap="square" lIns="0" tIns="0" rIns="0" bIns="0" rtlCol="0" anchor="ctr"/>
-          <a:lstStyle/>
+            <a:off x="713232" y="3580000"/>
+            <a:ext cx="9692640" cy="1440000"/>
+          </a:xfrm>
+          <a:prstGeom prst="rect">
+            <a:avLst/>
+          </a:prstGeom>
+          <a:noFill/>
+          <a:ln/>
+        </p:spPr>
+        <p:txBody>
+          <a:bodyPr wrap="square" lIns="0" tIns="0" rIns="0" bIns="0" rtlCol="0" anchor="ctr"/>
+          <a:lstStyle/>
+          <a:p>
+            <a:pPr algn="l" indent="0" marL="0">
+              <a:lnSpc>
+                <a:spcPct val="110000"/>
+              </a:lnSpc>
+              <a:spcAft>
+                <a:spcPts val="600"/>
+              </a:spcAft>
+              <a:buNone/>
+            </a:pPr>
+            <a:r>
+              <a:rPr lang="en-US" sz="3000" b="1" i="1" dirty="0">
+                <a:solidFill>
+                  <a:srgbClr val="FFFFFF"/>
+                </a:solidFill>
+                <a:latin typeface="Arial" pitchFamily="34" charset="0"/>
+                <a:ea typeface="Arial" pitchFamily="34" charset="-122"/>
+                <a:cs typeface="Arial" pitchFamily="34" charset="-120"/>
+              </a:rPr>
+              <a:t xml:space="preserve">Onboarding, made </a:t>
+            </a:r>
+            <a:r>
+              <a:rPr lang="en-US" sz="3000" b="1" i="1" dirty="0">
+                <a:solidFill>
+                  <a:srgbClr val="F97316"/>
+                </a:solidFill>
+                <a:latin typeface="Arial" pitchFamily="34" charset="0"/>
+                <a:ea typeface="Arial" pitchFamily="34" charset="-122"/>
+                <a:cs typeface="Arial" pitchFamily="34" charset="-120"/>
+              </a:rPr>
+              <a:t>effortless.</a:t>
+            </a:r>
+            <a:endParaRPr lang="en-US" sz="3000" b="1" i="1" dirty="0"/>
+          </a:p>
           <a:p>
             <a:pPr algn="l" indent="0" marL="0">
               <a:lnSpc>
@@ -2799,7 +2835,7 @@
                 <a:ea typeface="Arial" pitchFamily="34" charset="-122"/>
                 <a:cs typeface="Arial" pitchFamily="34" charset="-120"/>
               </a:rPr>
-              <a:t>2 / 7</a:t>
+              <a:t>2 / 9</a:t>
             </a:r>
             <a:endParaRPr lang="en-US" sz="950" dirty="0"/>
           </a:p>
@@ -4112,7 +4148,7 @@
                 <a:ea typeface="Arial" pitchFamily="34" charset="-122"/>
                 <a:cs typeface="Arial" pitchFamily="34" charset="-120"/>
               </a:rPr>
-              <a:t>3 / 7</a:t>
+              <a:t>3 / 9</a:t>
             </a:r>
             <a:endParaRPr lang="en-US" sz="950" dirty="0"/>
           </a:p>
@@ -5480,7 +5516,7 @@
                 <a:ea typeface="Arial" pitchFamily="34" charset="-122"/>
                 <a:cs typeface="Arial" pitchFamily="34" charset="-120"/>
               </a:rPr>
-              <a:t>4 / 7</a:t>
+              <a:t>4 / 9</a:t>
             </a:r>
             <a:endParaRPr lang="en-US" sz="950" dirty="0"/>
           </a:p>
@@ -5610,7 +5646,7 @@
                 <a:ea typeface="Arial" pitchFamily="34" charset="-122"/>
                 <a:cs typeface="Arial" pitchFamily="34" charset="-120"/>
               </a:rPr>
-              <a:t>26 tools, one queue</a:t>
+              <a:t>24 tools, one queue</a:t>
             </a:r>
             <a:endParaRPr lang="en-US" sz="3000" dirty="0"/>
           </a:p>
@@ -6574,7 +6610,7 @@
                 <a:ea typeface="Arial" pitchFamily="34" charset="-122"/>
                 <a:cs typeface="Arial" pitchFamily="34" charset="-120"/>
               </a:rPr>
-              <a:t>Pre-flight permissions, diff against the target zone, and Apply-time ruleset re-merge so writes never clobber existing rules.</a:t>
+              <a:t>Pre-flight permissions, target-zone diff, post-migration Verify, and Apply-time ruleset re-merge so writes never clobber existing rules.</a:t>
             </a:r>
             <a:endParaRPr lang="en-US" sz="1150" dirty="0"/>
           </a:p>
@@ -6952,7 +6988,7 @@
                 <a:ea typeface="Arial" pitchFamily="34" charset="-122"/>
                 <a:cs typeface="Arial" pitchFamily="34" charset="-120"/>
               </a:rPr>
-              <a:t>5 / 7</a:t>
+              <a:t>5 / 9</a:t>
             </a:r>
             <a:endParaRPr lang="en-US" sz="950" dirty="0"/>
           </a:p>
@@ -7569,7 +7605,7 @@
                 <a:ea typeface="Arial" pitchFamily="34" charset="-122"/>
                 <a:cs typeface="Arial" pitchFamily="34" charset="-120"/>
               </a:rPr>
-              <a:t>Safer Apply</a:t>
+              <a:t>Signed email approvals</a:t>
             </a:r>
             <a:endParaRPr lang="en-US" sz="1450" dirty="0"/>
           </a:p>
@@ -7608,7 +7644,7 @@
                 <a:ea typeface="Arial" pitchFamily="34" charset="-122"/>
                 <a:cs typeface="Arial" pitchFamily="34" charset="-120"/>
               </a:rPr>
-              <a:t>Batched, dependency-ordered applies with per-action dry-run diffs and auto-rollback from snapshots on failure.</a:t>
+              <a:t>Approve or reject a queued change straight from an email link, secured with per-recipient signed tokens.</a:t>
             </a:r>
             <a:endParaRPr lang="en-US" sz="1080" dirty="0"/>
           </a:p>
@@ -7735,7 +7771,7 @@
                 <a:ea typeface="Arial" pitchFamily="34" charset="-122"/>
                 <a:cs typeface="Arial" pitchFamily="34" charset="-120"/>
               </a:rPr>
-              <a:t>Proactive posture</a:t>
+              <a:t>Compliance evidence pack</a:t>
             </a:r>
             <a:endParaRPr lang="en-US" sz="1450" dirty="0"/>
           </a:p>
@@ -7774,7 +7810,7 @@
                 <a:ea typeface="Arial" pitchFamily="34" charset="-122"/>
                 <a:cs typeface="Arial" pitchFamily="34" charset="-120"/>
               </a:rPr>
-              <a:t>Scheduled health checks and config-drift detection against a desired baseline.</a:t>
+              <a:t>Turn the security-posture scorecard and audit trail into exportable SOC 2 / PCI evidence.</a:t>
             </a:r>
             <a:endParaRPr lang="en-US" sz="1080" dirty="0"/>
           </a:p>
@@ -8820,7 +8856,2125 @@
                 <a:ea typeface="Arial" pitchFamily="34" charset="-122"/>
                 <a:cs typeface="Arial" pitchFamily="34" charset="-120"/>
               </a:rPr>
-              <a:t>6 / 7</a:t>
+              <a:t>6 / 9</a:t>
+            </a:r>
+            <a:endParaRPr lang="en-US" sz="950" dirty="0"/>
+          </a:p>
+        </p:txBody>
+      </p:sp>
+    </p:spTree>
+  </p:cSld>
+  <p:clrMapOvr>
+    <a:masterClrMapping/>
+  </p:clrMapOvr>
+</p:sld>
+</file>
+
+<file path=ppt/slides/slide8.xml><?xml version="1.0" encoding="utf-8"?>
+<p:sld xmlns:a="http://schemas.openxmlformats.org/drawingml/2006/main" xmlns:r="http://schemas.openxmlformats.org/officeDocument/2006/relationships" xmlns:p="http://schemas.openxmlformats.org/presentationml/2006/main">
+  <p:cSld name="Slide 5">
+    <p:bg>
+      <p:bgPr>
+        <a:solidFill>
+          <a:srgbClr val="F6F7FA"/>
+        </a:solidFill>
+      </p:bgPr>
+    </p:bg>
+    <p:spTree>
+      <p:nvGrpSpPr>
+        <p:cNvPr id="1" name=""/>
+        <p:cNvGrpSpPr/>
+        <p:nvPr/>
+      </p:nvGrpSpPr>
+      <p:grpSpPr>
+        <a:xfrm>
+          <a:off x="0" y="0"/>
+          <a:ext cx="0" cy="0"/>
+          <a:chOff x="0" y="0"/>
+          <a:chExt cx="0" cy="0"/>
+        </a:xfrm>
+      </p:grpSpPr>
+      <p:sp>
+        <p:nvSpPr>
+          <p:cNvPr id="2" name="Shape 0"/>
+          <p:cNvSpPr/>
+          <p:nvPr/>
+        </p:nvSpPr>
+        <p:spPr>
+          <a:xfrm>
+            <a:off x="0" y="0"/>
+            <a:ext cx="164592" cy="6858000"/>
+          </a:xfrm>
+          <a:prstGeom prst="rect">
+            <a:avLst/>
+          </a:prstGeom>
+          <a:solidFill>
+            <a:srgbClr val="F97316"/>
+          </a:solidFill>
+          <a:ln/>
+        </p:spPr>
+      </p:sp>
+      <p:sp>
+        <p:nvSpPr>
+          <p:cNvPr id="3" name="Text 1"/>
+          <p:cNvSpPr/>
+          <p:nvPr/>
+        </p:nvSpPr>
+        <p:spPr>
+          <a:xfrm>
+            <a:off x="640080" y="502920"/>
+            <a:ext cx="7315200" cy="292608"/>
+          </a:xfrm>
+          <a:prstGeom prst="rect">
+            <a:avLst/>
+          </a:prstGeom>
+          <a:noFill/>
+          <a:ln/>
+        </p:spPr>
+        <p:txBody>
+          <a:bodyPr wrap="square" lIns="0" tIns="0" rIns="0" bIns="0" rtlCol="0" anchor="ctr"/>
+          <a:lstStyle/>
+          <a:p>
+            <a:pPr algn="l" indent="0" marL="0">
+              <a:buNone/>
+            </a:pPr>
+            <a:r>
+              <a:rPr lang="en-US" sz="1200" b="1" spc="300" kern="0" dirty="0">
+                <a:solidFill>
+                  <a:srgbClr val="F97316"/>
+                </a:solidFill>
+                <a:latin typeface="Arial" pitchFamily="34" charset="0"/>
+                <a:ea typeface="Arial" pitchFamily="34" charset="-122"/>
+                <a:cs typeface="Arial" pitchFamily="34" charset="-120"/>
+              </a:rPr>
+              <a:t>GOVERNANCE &amp; CONTROL</a:t>
+            </a:r>
+            <a:endParaRPr lang="en-US" sz="1200" dirty="0"/>
+          </a:p>
+        </p:txBody>
+      </p:sp>
+      <p:sp>
+        <p:nvSpPr>
+          <p:cNvPr id="4" name="Text 2"/>
+          <p:cNvSpPr/>
+          <p:nvPr/>
+        </p:nvSpPr>
+        <p:spPr>
+          <a:xfrm>
+            <a:off x="621792" y="777240"/>
+            <a:ext cx="10881360" cy="640080"/>
+          </a:xfrm>
+          <a:prstGeom prst="rect">
+            <a:avLst/>
+          </a:prstGeom>
+          <a:noFill/>
+          <a:ln/>
+        </p:spPr>
+        <p:txBody>
+          <a:bodyPr wrap="square" lIns="0" tIns="0" rIns="0" bIns="0" rtlCol="0" anchor="ctr"/>
+          <a:lstStyle/>
+          <a:p>
+            <a:pPr algn="l" indent="0" marL="0">
+              <a:buNone/>
+            </a:pPr>
+            <a:r>
+              <a:rPr lang="en-US" sz="3000" b="1" dirty="0">
+                <a:solidFill>
+                  <a:srgbClr val="0F172A"/>
+                </a:solidFill>
+                <a:latin typeface="Arial" pitchFamily="34" charset="0"/>
+                <a:ea typeface="Arial" pitchFamily="34" charset="-122"/>
+                <a:cs typeface="Arial" pitchFamily="34" charset="-120"/>
+              </a:rPr>
+              <a:t>Every change, under control.</a:t>
+            </a:r>
+            <a:endParaRPr lang="en-US" sz="3000" dirty="0"/>
+          </a:p>
+        </p:txBody>
+      </p:sp>
+      <p:sp>
+        <p:nvSpPr>
+          <p:cNvPr id="5" name="Text 3"/>
+          <p:cNvSpPr/>
+          <p:nvPr/>
+        </p:nvSpPr>
+        <p:spPr>
+          <a:xfrm>
+            <a:off x="640080" y="1463040"/>
+            <a:ext cx="10789920" cy="365760"/>
+          </a:xfrm>
+          <a:prstGeom prst="rect">
+            <a:avLst/>
+          </a:prstGeom>
+          <a:noFill/>
+          <a:ln/>
+        </p:spPr>
+        <p:txBody>
+          <a:bodyPr wrap="square" lIns="0" tIns="0" rIns="0" bIns="0" rtlCol="0" anchor="ctr"/>
+          <a:lstStyle/>
+          <a:p>
+            <a:pPr algn="l" indent="0" marL="0">
+              <a:buNone/>
+            </a:pPr>
+            <a:r>
+              <a:rPr lang="en-US" sz="1350" dirty="0">
+                <a:solidFill>
+                  <a:srgbClr val="475569"/>
+                </a:solidFill>
+                <a:latin typeface="Arial" pitchFamily="34" charset="0"/>
+                <a:ea typeface="Arial" pitchFamily="34" charset="-122"/>
+                <a:cs typeface="Arial" pitchFamily="34" charset="-120"/>
+              </a:rPr>
+              <a:t>Beyond queue-and-Apply: score posture, preview blast radius, require sign-off, schedule windows, and auto-revert — all audited.</a:t>
+            </a:r>
+            <a:endParaRPr lang="en-US" sz="1350" dirty="0"/>
+          </a:p>
+        </p:txBody>
+      </p:sp>
+      <p:sp>
+        <p:nvSpPr>
+          <p:cNvPr id="6" name="Shape 4"/>
+          <p:cNvSpPr/>
+          <p:nvPr/>
+        </p:nvSpPr>
+        <p:spPr>
+          <a:xfrm>
+            <a:off x="640080" y="2011680"/>
+            <a:ext cx="3502152" cy="1956816"/>
+          </a:xfrm>
+          <a:prstGeom prst="rect">
+            <a:avLst/>
+          </a:prstGeom>
+          <a:solidFill>
+            <a:srgbClr val="FFFFFF"/>
+          </a:solidFill>
+          <a:ln w="12700">
+            <a:solidFill>
+              <a:srgbClr val="E2E8F0"/>
+            </a:solidFill>
+            <a:prstDash val="solid"/>
+          </a:ln>
+          <a:effectLst>
+            <a:outerShdw sx="100000" sy="100000" kx="0" ky="0" algn="bl" rotWithShape="0" blurRad="114300" dist="38100" dir="5400000">
+              <a:srgbClr val="0B1220">
+                <a:alpha val="16000"/>
+              </a:srgbClr>
+            </a:outerShdw>
+          </a:effectLst>
+        </p:spPr>
+      </p:sp>
+      <p:sp>
+        <p:nvSpPr>
+          <p:cNvPr id="7" name="Shape 5"/>
+          <p:cNvSpPr/>
+          <p:nvPr/>
+        </p:nvSpPr>
+        <p:spPr>
+          <a:xfrm>
+            <a:off x="640080" y="2011680"/>
+            <a:ext cx="3502152" cy="82296"/>
+          </a:xfrm>
+          <a:prstGeom prst="rect">
+            <a:avLst/>
+          </a:prstGeom>
+          <a:solidFill>
+            <a:srgbClr val="F97316"/>
+          </a:solidFill>
+          <a:ln/>
+        </p:spPr>
+      </p:sp>
+      <p:sp>
+        <p:nvSpPr>
+          <p:cNvPr id="8" name="Text 6"/>
+          <p:cNvSpPr/>
+          <p:nvPr/>
+        </p:nvSpPr>
+        <p:spPr>
+          <a:xfrm>
+            <a:off x="896112" y="2231136"/>
+            <a:ext cx="3044952" cy="347472"/>
+          </a:xfrm>
+          <a:prstGeom prst="rect">
+            <a:avLst/>
+          </a:prstGeom>
+          <a:noFill/>
+          <a:ln/>
+        </p:spPr>
+        <p:txBody>
+          <a:bodyPr wrap="square" lIns="0" tIns="0" rIns="0" bIns="0" rtlCol="0" anchor="ctr"/>
+          <a:lstStyle/>
+          <a:p>
+            <a:pPr algn="l" indent="0" marL="0">
+              <a:buNone/>
+            </a:pPr>
+            <a:r>
+              <a:rPr lang="en-US" sz="1550" b="1" dirty="0">
+                <a:solidFill>
+                  <a:srgbClr val="0F172A"/>
+                </a:solidFill>
+                <a:latin typeface="Arial" pitchFamily="34" charset="0"/>
+                <a:ea typeface="Arial" pitchFamily="34" charset="-122"/>
+                <a:cs typeface="Arial" pitchFamily="34" charset="-120"/>
+              </a:rPr>
+              <a:t>Security posture</a:t>
+            </a:r>
+            <a:endParaRPr lang="en-US" sz="1550" dirty="0"/>
+          </a:p>
+        </p:txBody>
+      </p:sp>
+      <p:sp>
+        <p:nvSpPr>
+          <p:cNvPr id="9" name="Text 7"/>
+          <p:cNvSpPr/>
+          <p:nvPr/>
+        </p:nvSpPr>
+        <p:spPr>
+          <a:xfrm>
+            <a:off x="896112" y="2615184"/>
+            <a:ext cx="3026664" cy="786384"/>
+          </a:xfrm>
+          <a:prstGeom prst="rect">
+            <a:avLst/>
+          </a:prstGeom>
+          <a:noFill/>
+          <a:ln/>
+        </p:spPr>
+        <p:txBody>
+          <a:bodyPr wrap="square" lIns="0" tIns="0" rIns="0" bIns="0" rtlCol="0" anchor="ctr"/>
+          <a:lstStyle/>
+          <a:p>
+            <a:pPr algn="l" indent="0" marL="0">
+              <a:lnSpc>
+                <a:spcPct val="113000"/>
+              </a:lnSpc>
+              <a:buNone/>
+            </a:pPr>
+            <a:r>
+              <a:rPr lang="en-US" sz="1150" dirty="0">
+                <a:solidFill>
+                  <a:srgbClr val="475569"/>
+                </a:solidFill>
+                <a:latin typeface="Arial" pitchFamily="34" charset="0"/>
+                <a:ea typeface="Arial" pitchFamily="34" charset="-122"/>
+                <a:cs typeface="Arial" pitchFamily="34" charset="-120"/>
+              </a:rPr>
+              <a:t>Grade the zone's live TLS / WAF / DNS / Network config into an A–F scorecard with one-click fixes to queue.</a:t>
+            </a:r>
+            <a:endParaRPr lang="en-US" sz="1150" dirty="0"/>
+          </a:p>
+        </p:txBody>
+      </p:sp>
+      <p:sp>
+        <p:nvSpPr>
+          <p:cNvPr id="10" name="Shape 8"/>
+          <p:cNvSpPr/>
+          <p:nvPr/>
+        </p:nvSpPr>
+        <p:spPr>
+          <a:xfrm>
+            <a:off x="896112" y="3456432"/>
+            <a:ext cx="2990088" cy="0"/>
+          </a:xfrm>
+          <a:prstGeom prst="line">
+            <a:avLst/>
+          </a:prstGeom>
+          <a:noFill/>
+          <a:ln w="12700">
+            <a:solidFill>
+              <a:srgbClr val="E2E8F0"/>
+            </a:solidFill>
+            <a:prstDash val="solid"/>
+          </a:ln>
+        </p:spPr>
+      </p:sp>
+      <p:sp>
+        <p:nvSpPr>
+          <p:cNvPr id="11" name="Text 9"/>
+          <p:cNvSpPr/>
+          <p:nvPr/>
+        </p:nvSpPr>
+        <p:spPr>
+          <a:xfrm>
+            <a:off x="896112" y="3511296"/>
+            <a:ext cx="3026664" cy="384048"/>
+          </a:xfrm>
+          <a:prstGeom prst="rect">
+            <a:avLst/>
+          </a:prstGeom>
+          <a:noFill/>
+          <a:ln/>
+        </p:spPr>
+        <p:txBody>
+          <a:bodyPr wrap="square" lIns="0" tIns="0" rIns="0" bIns="0" rtlCol="0" anchor="ctr"/>
+          <a:lstStyle/>
+          <a:p>
+            <a:pPr algn="l" indent="0" marL="0">
+              <a:lnSpc>
+                <a:spcPct val="105000"/>
+              </a:lnSpc>
+              <a:buNone/>
+            </a:pPr>
+            <a:r>
+              <a:rPr lang="en-US" sz="880" dirty="0">
+                <a:solidFill>
+                  <a:srgbClr val="64748B"/>
+                </a:solidFill>
+                <a:latin typeface="Courier New" pitchFamily="34" charset="0"/>
+                <a:ea typeface="Courier New" pitchFamily="34" charset="-122"/>
+                <a:cs typeface="Courier New" pitchFamily="34" charset="-120"/>
+              </a:rPr>
+              <a:t>security_posture · queuePostureFix</a:t>
+            </a:r>
+            <a:endParaRPr lang="en-US" sz="880" dirty="0"/>
+          </a:p>
+        </p:txBody>
+      </p:sp>
+      <p:sp>
+        <p:nvSpPr>
+          <p:cNvPr id="12" name="Shape 10"/>
+          <p:cNvSpPr/>
+          <p:nvPr/>
+        </p:nvSpPr>
+        <p:spPr>
+          <a:xfrm>
+            <a:off x="4279392" y="2011680"/>
+            <a:ext cx="3502152" cy="1956816"/>
+          </a:xfrm>
+          <a:prstGeom prst="rect">
+            <a:avLst/>
+          </a:prstGeom>
+          <a:solidFill>
+            <a:srgbClr val="FFFFFF"/>
+          </a:solidFill>
+          <a:ln w="12700">
+            <a:solidFill>
+              <a:srgbClr val="E2E8F0"/>
+            </a:solidFill>
+            <a:prstDash val="solid"/>
+          </a:ln>
+          <a:effectLst>
+            <a:outerShdw sx="100000" sy="100000" kx="0" ky="0" algn="bl" rotWithShape="0" blurRad="114300" dist="38100" dir="5400000">
+              <a:srgbClr val="0B1220">
+                <a:alpha val="16000"/>
+              </a:srgbClr>
+            </a:outerShdw>
+          </a:effectLst>
+        </p:spPr>
+      </p:sp>
+      <p:sp>
+        <p:nvSpPr>
+          <p:cNvPr id="13" name="Shape 11"/>
+          <p:cNvSpPr/>
+          <p:nvPr/>
+        </p:nvSpPr>
+        <p:spPr>
+          <a:xfrm>
+            <a:off x="4279392" y="2011680"/>
+            <a:ext cx="3502152" cy="82296"/>
+          </a:xfrm>
+          <a:prstGeom prst="rect">
+            <a:avLst/>
+          </a:prstGeom>
+          <a:solidFill>
+            <a:srgbClr val="38BDF8"/>
+          </a:solidFill>
+          <a:ln/>
+        </p:spPr>
+      </p:sp>
+      <p:sp>
+        <p:nvSpPr>
+          <p:cNvPr id="14" name="Text 12"/>
+          <p:cNvSpPr/>
+          <p:nvPr/>
+        </p:nvSpPr>
+        <p:spPr>
+          <a:xfrm>
+            <a:off x="4535424" y="2231136"/>
+            <a:ext cx="3044952" cy="347472"/>
+          </a:xfrm>
+          <a:prstGeom prst="rect">
+            <a:avLst/>
+          </a:prstGeom>
+          <a:noFill/>
+          <a:ln/>
+        </p:spPr>
+        <p:txBody>
+          <a:bodyPr wrap="square" lIns="0" tIns="0" rIns="0" bIns="0" rtlCol="0" anchor="ctr"/>
+          <a:lstStyle/>
+          <a:p>
+            <a:pPr algn="l" indent="0" marL="0">
+              <a:buNone/>
+            </a:pPr>
+            <a:r>
+              <a:rPr lang="en-US" sz="1550" b="1" dirty="0">
+                <a:solidFill>
+                  <a:srgbClr val="0F172A"/>
+                </a:solidFill>
+                <a:latin typeface="Arial" pitchFamily="34" charset="0"/>
+                <a:ea typeface="Arial" pitchFamily="34" charset="-122"/>
+                <a:cs typeface="Arial" pitchFamily="34" charset="-120"/>
+              </a:rPr>
+              <a:t>Drift watch</a:t>
+            </a:r>
+            <a:endParaRPr lang="en-US" sz="1550" dirty="0"/>
+          </a:p>
+        </p:txBody>
+      </p:sp>
+      <p:sp>
+        <p:nvSpPr>
+          <p:cNvPr id="15" name="Text 13"/>
+          <p:cNvSpPr/>
+          <p:nvPr/>
+        </p:nvSpPr>
+        <p:spPr>
+          <a:xfrm>
+            <a:off x="4535424" y="2615184"/>
+            <a:ext cx="3026664" cy="786384"/>
+          </a:xfrm>
+          <a:prstGeom prst="rect">
+            <a:avLst/>
+          </a:prstGeom>
+          <a:noFill/>
+          <a:ln/>
+        </p:spPr>
+        <p:txBody>
+          <a:bodyPr wrap="square" lIns="0" tIns="0" rIns="0" bIns="0" rtlCol="0" anchor="ctr"/>
+          <a:lstStyle/>
+          <a:p>
+            <a:pPr algn="l" indent="0" marL="0">
+              <a:lnSpc>
+                <a:spcPct val="113000"/>
+              </a:lnSpc>
+              <a:buNone/>
+            </a:pPr>
+            <a:r>
+              <a:rPr lang="en-US" sz="1150" dirty="0">
+                <a:solidFill>
+                  <a:srgbClr val="475569"/>
+                </a:solidFill>
+                <a:latin typeface="Arial" pitchFamily="34" charset="0"/>
+                <a:ea typeface="Arial" pitchFamily="34" charset="-122"/>
+                <a:cs typeface="Arial" pitchFamily="34" charset="-120"/>
+              </a:rPr>
+              <a:t>Re-score the zone weekly against a saved baseline and flag any drift in posture.</a:t>
+            </a:r>
+            <a:endParaRPr lang="en-US" sz="1150" dirty="0"/>
+          </a:p>
+        </p:txBody>
+      </p:sp>
+      <p:sp>
+        <p:nvSpPr>
+          <p:cNvPr id="16" name="Shape 14"/>
+          <p:cNvSpPr/>
+          <p:nvPr/>
+        </p:nvSpPr>
+        <p:spPr>
+          <a:xfrm>
+            <a:off x="4535424" y="3456432"/>
+            <a:ext cx="2990088" cy="0"/>
+          </a:xfrm>
+          <a:prstGeom prst="line">
+            <a:avLst/>
+          </a:prstGeom>
+          <a:noFill/>
+          <a:ln w="12700">
+            <a:solidFill>
+              <a:srgbClr val="E2E8F0"/>
+            </a:solidFill>
+            <a:prstDash val="solid"/>
+          </a:ln>
+        </p:spPr>
+      </p:sp>
+      <p:sp>
+        <p:nvSpPr>
+          <p:cNvPr id="17" name="Text 15"/>
+          <p:cNvSpPr/>
+          <p:nvPr/>
+        </p:nvSpPr>
+        <p:spPr>
+          <a:xfrm>
+            <a:off x="4535424" y="3511296"/>
+            <a:ext cx="3026664" cy="384048"/>
+          </a:xfrm>
+          <a:prstGeom prst="rect">
+            <a:avLst/>
+          </a:prstGeom>
+          <a:noFill/>
+          <a:ln/>
+        </p:spPr>
+        <p:txBody>
+          <a:bodyPr wrap="square" lIns="0" tIns="0" rIns="0" bIns="0" rtlCol="0" anchor="ctr"/>
+          <a:lstStyle/>
+          <a:p>
+            <a:pPr algn="l" indent="0" marL="0">
+              <a:lnSpc>
+                <a:spcPct val="105000"/>
+              </a:lnSpc>
+              <a:buNone/>
+            </a:pPr>
+            <a:r>
+              <a:rPr lang="en-US" sz="880" dirty="0">
+                <a:solidFill>
+                  <a:srgbClr val="64748B"/>
+                </a:solidFill>
+                <a:latin typeface="Courier New" pitchFamily="34" charset="0"/>
+                <a:ea typeface="Courier New" pitchFamily="34" charset="-122"/>
+                <a:cs typeface="Courier New" pitchFamily="34" charset="-120"/>
+              </a:rPr>
+              <a:t>setPostureBaseline · setDriftWatch</a:t>
+            </a:r>
+            <a:endParaRPr lang="en-US" sz="880" dirty="0"/>
+          </a:p>
+        </p:txBody>
+      </p:sp>
+      <p:sp>
+        <p:nvSpPr>
+          <p:cNvPr id="18" name="Shape 16"/>
+          <p:cNvSpPr/>
+          <p:nvPr/>
+        </p:nvSpPr>
+        <p:spPr>
+          <a:xfrm>
+            <a:off x="7918704" y="2011680"/>
+            <a:ext cx="3502152" cy="1956816"/>
+          </a:xfrm>
+          <a:prstGeom prst="rect">
+            <a:avLst/>
+          </a:prstGeom>
+          <a:solidFill>
+            <a:srgbClr val="FFFFFF"/>
+          </a:solidFill>
+          <a:ln w="12700">
+            <a:solidFill>
+              <a:srgbClr val="E2E8F0"/>
+            </a:solidFill>
+            <a:prstDash val="solid"/>
+          </a:ln>
+          <a:effectLst>
+            <a:outerShdw sx="100000" sy="100000" kx="0" ky="0" algn="bl" rotWithShape="0" blurRad="114300" dist="38100" dir="5400000">
+              <a:srgbClr val="0B1220">
+                <a:alpha val="16000"/>
+              </a:srgbClr>
+            </a:outerShdw>
+          </a:effectLst>
+        </p:spPr>
+      </p:sp>
+      <p:sp>
+        <p:nvSpPr>
+          <p:cNvPr id="19" name="Shape 17"/>
+          <p:cNvSpPr/>
+          <p:nvPr/>
+        </p:nvSpPr>
+        <p:spPr>
+          <a:xfrm>
+            <a:off x="7918704" y="2011680"/>
+            <a:ext cx="3502152" cy="82296"/>
+          </a:xfrm>
+          <a:prstGeom prst="rect">
+            <a:avLst/>
+          </a:prstGeom>
+          <a:solidFill>
+            <a:srgbClr val="FBBF24"/>
+          </a:solidFill>
+          <a:ln/>
+        </p:spPr>
+      </p:sp>
+      <p:sp>
+        <p:nvSpPr>
+          <p:cNvPr id="20" name="Text 18"/>
+          <p:cNvSpPr/>
+          <p:nvPr/>
+        </p:nvSpPr>
+        <p:spPr>
+          <a:xfrm>
+            <a:off x="8174736" y="2231136"/>
+            <a:ext cx="3044952" cy="347472"/>
+          </a:xfrm>
+          <a:prstGeom prst="rect">
+            <a:avLst/>
+          </a:prstGeom>
+          <a:noFill/>
+          <a:ln/>
+        </p:spPr>
+        <p:txBody>
+          <a:bodyPr wrap="square" lIns="0" tIns="0" rIns="0" bIns="0" rtlCol="0" anchor="ctr"/>
+          <a:lstStyle/>
+          <a:p>
+            <a:pPr algn="l" indent="0" marL="0">
+              <a:buNone/>
+            </a:pPr>
+            <a:r>
+              <a:rPr lang="en-US" sz="1550" b="1" dirty="0">
+                <a:solidFill>
+                  <a:srgbClr val="0F172A"/>
+                </a:solidFill>
+                <a:latin typeface="Arial" pitchFamily="34" charset="0"/>
+                <a:ea typeface="Arial" pitchFamily="34" charset="-122"/>
+                <a:cs typeface="Arial" pitchFamily="34" charset="-120"/>
+              </a:rPr>
+              <a:t>Blast radius</a:t>
+            </a:r>
+            <a:endParaRPr lang="en-US" sz="1550" dirty="0"/>
+          </a:p>
+        </p:txBody>
+      </p:sp>
+      <p:sp>
+        <p:nvSpPr>
+          <p:cNvPr id="21" name="Text 19"/>
+          <p:cNvSpPr/>
+          <p:nvPr/>
+        </p:nvSpPr>
+        <p:spPr>
+          <a:xfrm>
+            <a:off x="8174736" y="2615184"/>
+            <a:ext cx="3026664" cy="786384"/>
+          </a:xfrm>
+          <a:prstGeom prst="rect">
+            <a:avLst/>
+          </a:prstGeom>
+          <a:noFill/>
+          <a:ln/>
+        </p:spPr>
+        <p:txBody>
+          <a:bodyPr wrap="square" lIns="0" tIns="0" rIns="0" bIns="0" rtlCol="0" anchor="ctr"/>
+          <a:lstStyle/>
+          <a:p>
+            <a:pPr algn="l" indent="0" marL="0">
+              <a:lnSpc>
+                <a:spcPct val="113000"/>
+              </a:lnSpc>
+              <a:buNone/>
+            </a:pPr>
+            <a:r>
+              <a:rPr lang="en-US" sz="1150" dirty="0">
+                <a:solidFill>
+                  <a:srgbClr val="475569"/>
+                </a:solidFill>
+                <a:latin typeface="Arial" pitchFamily="34" charset="0"/>
+                <a:ea typeface="Arial" pitchFamily="34" charset="-122"/>
+                <a:cs typeface="Arial" pitchFamily="34" charset="-120"/>
+              </a:rPr>
+              <a:t>Estimate how much real last-24h traffic a queued change touches — before anyone clicks Apply.</a:t>
+            </a:r>
+            <a:endParaRPr lang="en-US" sz="1150" dirty="0"/>
+          </a:p>
+        </p:txBody>
+      </p:sp>
+      <p:sp>
+        <p:nvSpPr>
+          <p:cNvPr id="22" name="Shape 20"/>
+          <p:cNvSpPr/>
+          <p:nvPr/>
+        </p:nvSpPr>
+        <p:spPr>
+          <a:xfrm>
+            <a:off x="8174736" y="3456432"/>
+            <a:ext cx="2990088" cy="0"/>
+          </a:xfrm>
+          <a:prstGeom prst="line">
+            <a:avLst/>
+          </a:prstGeom>
+          <a:noFill/>
+          <a:ln w="12700">
+            <a:solidFill>
+              <a:srgbClr val="E2E8F0"/>
+            </a:solidFill>
+            <a:prstDash val="solid"/>
+          </a:ln>
+        </p:spPr>
+      </p:sp>
+      <p:sp>
+        <p:nvSpPr>
+          <p:cNvPr id="23" name="Text 21"/>
+          <p:cNvSpPr/>
+          <p:nvPr/>
+        </p:nvSpPr>
+        <p:spPr>
+          <a:xfrm>
+            <a:off x="8174736" y="3511296"/>
+            <a:ext cx="3026664" cy="384048"/>
+          </a:xfrm>
+          <a:prstGeom prst="rect">
+            <a:avLst/>
+          </a:prstGeom>
+          <a:noFill/>
+          <a:ln/>
+        </p:spPr>
+        <p:txBody>
+          <a:bodyPr wrap="square" lIns="0" tIns="0" rIns="0" bIns="0" rtlCol="0" anchor="ctr"/>
+          <a:lstStyle/>
+          <a:p>
+            <a:pPr algn="l" indent="0" marL="0">
+              <a:lnSpc>
+                <a:spcPct val="105000"/>
+              </a:lnSpc>
+              <a:buNone/>
+            </a:pPr>
+            <a:r>
+              <a:rPr lang="en-US" sz="880" dirty="0">
+                <a:solidFill>
+                  <a:srgbClr val="B45309"/>
+                </a:solidFill>
+                <a:latin typeface="Courier New" pitchFamily="34" charset="0"/>
+                <a:ea typeface="Courier New" pitchFamily="34" charset="-122"/>
+                <a:cs typeface="Courier New" pitchFamily="34" charset="-120"/>
+              </a:rPr>
+              <a:t>estimate_impact</a:t>
+            </a:r>
+            <a:endParaRPr lang="en-US" sz="880" dirty="0"/>
+          </a:p>
+        </p:txBody>
+      </p:sp>
+      <p:sp>
+        <p:nvSpPr>
+          <p:cNvPr id="24" name="Shape 22"/>
+          <p:cNvSpPr/>
+          <p:nvPr/>
+        </p:nvSpPr>
+        <p:spPr>
+          <a:xfrm>
+            <a:off x="640080" y="4151376"/>
+            <a:ext cx="3502152" cy="1956816"/>
+          </a:xfrm>
+          <a:prstGeom prst="rect">
+            <a:avLst/>
+          </a:prstGeom>
+          <a:solidFill>
+            <a:srgbClr val="FFFFFF"/>
+          </a:solidFill>
+          <a:ln w="12700">
+            <a:solidFill>
+              <a:srgbClr val="E2E8F0"/>
+            </a:solidFill>
+            <a:prstDash val="solid"/>
+          </a:ln>
+          <a:effectLst>
+            <a:outerShdw sx="100000" sy="100000" kx="0" ky="0" algn="bl" rotWithShape="0" blurRad="114300" dist="38100" dir="5400000">
+              <a:srgbClr val="0B1220">
+                <a:alpha val="16000"/>
+              </a:srgbClr>
+            </a:outerShdw>
+          </a:effectLst>
+        </p:spPr>
+      </p:sp>
+      <p:sp>
+        <p:nvSpPr>
+          <p:cNvPr id="25" name="Shape 23"/>
+          <p:cNvSpPr/>
+          <p:nvPr/>
+        </p:nvSpPr>
+        <p:spPr>
+          <a:xfrm>
+            <a:off x="640080" y="4151376"/>
+            <a:ext cx="3502152" cy="82296"/>
+          </a:xfrm>
+          <a:prstGeom prst="rect">
+            <a:avLst/>
+          </a:prstGeom>
+          <a:solidFill>
+            <a:srgbClr val="8B5CF6"/>
+          </a:solidFill>
+          <a:ln/>
+        </p:spPr>
+      </p:sp>
+      <p:sp>
+        <p:nvSpPr>
+          <p:cNvPr id="26" name="Text 24"/>
+          <p:cNvSpPr/>
+          <p:nvPr/>
+        </p:nvSpPr>
+        <p:spPr>
+          <a:xfrm>
+            <a:off x="896112" y="4370832"/>
+            <a:ext cx="3044952" cy="347472"/>
+          </a:xfrm>
+          <a:prstGeom prst="rect">
+            <a:avLst/>
+          </a:prstGeom>
+          <a:noFill/>
+          <a:ln/>
+        </p:spPr>
+        <p:txBody>
+          <a:bodyPr wrap="square" lIns="0" tIns="0" rIns="0" bIns="0" rtlCol="0" anchor="ctr"/>
+          <a:lstStyle/>
+          <a:p>
+            <a:pPr algn="l" indent="0" marL="0">
+              <a:buNone/>
+            </a:pPr>
+            <a:r>
+              <a:rPr lang="en-US" sz="1550" b="1" dirty="0">
+                <a:solidFill>
+                  <a:srgbClr val="0F172A"/>
+                </a:solidFill>
+                <a:latin typeface="Arial" pitchFamily="34" charset="0"/>
+                <a:ea typeface="Arial" pitchFamily="34" charset="-122"/>
+                <a:cs typeface="Arial" pitchFamily="34" charset="-120"/>
+              </a:rPr>
+              <a:t>Auto-rollback</a:t>
+            </a:r>
+            <a:endParaRPr lang="en-US" sz="1550" dirty="0"/>
+          </a:p>
+        </p:txBody>
+      </p:sp>
+      <p:sp>
+        <p:nvSpPr>
+          <p:cNvPr id="27" name="Text 25"/>
+          <p:cNvSpPr/>
+          <p:nvPr/>
+        </p:nvSpPr>
+        <p:spPr>
+          <a:xfrm>
+            <a:off x="896112" y="4754880"/>
+            <a:ext cx="3026664" cy="786384"/>
+          </a:xfrm>
+          <a:prstGeom prst="rect">
+            <a:avLst/>
+          </a:prstGeom>
+          <a:noFill/>
+          <a:ln/>
+        </p:spPr>
+        <p:txBody>
+          <a:bodyPr wrap="square" lIns="0" tIns="0" rIns="0" bIns="0" rtlCol="0" anchor="ctr"/>
+          <a:lstStyle/>
+          <a:p>
+            <a:pPr algn="l" indent="0" marL="0">
+              <a:lnSpc>
+                <a:spcPct val="113000"/>
+              </a:lnSpc>
+              <a:buNone/>
+            </a:pPr>
+            <a:r>
+              <a:rPr lang="en-US" sz="1150" dirty="0">
+                <a:solidFill>
+                  <a:srgbClr val="475569"/>
+                </a:solidFill>
+                <a:latin typeface="Arial" pitchFamily="34" charset="0"/>
+                <a:ea typeface="Arial" pitchFamily="34" charset="-122"/>
+                <a:cs typeface="Arial" pitchFamily="34" charset="-120"/>
+              </a:rPr>
+              <a:t>Opt-in 15-minute revert window on invertible changes — Keep to confirm, or it reverts itself.</a:t>
+            </a:r>
+            <a:endParaRPr lang="en-US" sz="1150" dirty="0"/>
+          </a:p>
+        </p:txBody>
+      </p:sp>
+      <p:sp>
+        <p:nvSpPr>
+          <p:cNvPr id="28" name="Shape 26"/>
+          <p:cNvSpPr/>
+          <p:nvPr/>
+        </p:nvSpPr>
+        <p:spPr>
+          <a:xfrm>
+            <a:off x="896112" y="5596128"/>
+            <a:ext cx="2990088" cy="0"/>
+          </a:xfrm>
+          <a:prstGeom prst="line">
+            <a:avLst/>
+          </a:prstGeom>
+          <a:noFill/>
+          <a:ln w="12700">
+            <a:solidFill>
+              <a:srgbClr val="E2E8F0"/>
+            </a:solidFill>
+            <a:prstDash val="solid"/>
+          </a:ln>
+        </p:spPr>
+      </p:sp>
+      <p:sp>
+        <p:nvSpPr>
+          <p:cNvPr id="29" name="Text 27"/>
+          <p:cNvSpPr/>
+          <p:nvPr/>
+        </p:nvSpPr>
+        <p:spPr>
+          <a:xfrm>
+            <a:off x="896112" y="5650992"/>
+            <a:ext cx="3026664" cy="384048"/>
+          </a:xfrm>
+          <a:prstGeom prst="rect">
+            <a:avLst/>
+          </a:prstGeom>
+          <a:noFill/>
+          <a:ln/>
+        </p:spPr>
+        <p:txBody>
+          <a:bodyPr wrap="square" lIns="0" tIns="0" rIns="0" bIns="0" rtlCol="0" anchor="ctr"/>
+          <a:lstStyle/>
+          <a:p>
+            <a:pPr algn="l" indent="0" marL="0">
+              <a:lnSpc>
+                <a:spcPct val="105000"/>
+              </a:lnSpc>
+              <a:buNone/>
+            </a:pPr>
+            <a:r>
+              <a:rPr lang="en-US" sz="880" dirty="0">
+                <a:solidFill>
+                  <a:srgbClr val="64748B"/>
+                </a:solidFill>
+                <a:latin typeface="Courier New" pitchFamily="34" charset="0"/>
+                <a:ea typeface="Courier New" pitchFamily="34" charset="-122"/>
+                <a:cs typeface="Courier New" pitchFamily="34" charset="-120"/>
+              </a:rPr>
+              <a:t>keepAppliedChange · revertAppliedChange</a:t>
+            </a:r>
+            <a:endParaRPr lang="en-US" sz="880" dirty="0"/>
+          </a:p>
+        </p:txBody>
+      </p:sp>
+      <p:sp>
+        <p:nvSpPr>
+          <p:cNvPr id="30" name="Shape 28"/>
+          <p:cNvSpPr/>
+          <p:nvPr/>
+        </p:nvSpPr>
+        <p:spPr>
+          <a:xfrm>
+            <a:off x="4279392" y="4151376"/>
+            <a:ext cx="3502152" cy="1956816"/>
+          </a:xfrm>
+          <a:prstGeom prst="rect">
+            <a:avLst/>
+          </a:prstGeom>
+          <a:solidFill>
+            <a:srgbClr val="FFFFFF"/>
+          </a:solidFill>
+          <a:ln w="12700">
+            <a:solidFill>
+              <a:srgbClr val="E2E8F0"/>
+            </a:solidFill>
+            <a:prstDash val="solid"/>
+          </a:ln>
+          <a:effectLst>
+            <a:outerShdw sx="100000" sy="100000" kx="0" ky="0" algn="bl" rotWithShape="0" blurRad="114300" dist="38100" dir="5400000">
+              <a:srgbClr val="0B1220">
+                <a:alpha val="16000"/>
+              </a:srgbClr>
+            </a:outerShdw>
+          </a:effectLst>
+        </p:spPr>
+      </p:sp>
+      <p:sp>
+        <p:nvSpPr>
+          <p:cNvPr id="31" name="Shape 29"/>
+          <p:cNvSpPr/>
+          <p:nvPr/>
+        </p:nvSpPr>
+        <p:spPr>
+          <a:xfrm>
+            <a:off x="4279392" y="4151376"/>
+            <a:ext cx="3502152" cy="82296"/>
+          </a:xfrm>
+          <a:prstGeom prst="rect">
+            <a:avLst/>
+          </a:prstGeom>
+          <a:solidFill>
+            <a:srgbClr val="EC4899"/>
+          </a:solidFill>
+          <a:ln/>
+        </p:spPr>
+      </p:sp>
+      <p:sp>
+        <p:nvSpPr>
+          <p:cNvPr id="32" name="Text 30"/>
+          <p:cNvSpPr/>
+          <p:nvPr/>
+        </p:nvSpPr>
+        <p:spPr>
+          <a:xfrm>
+            <a:off x="4535424" y="4370832"/>
+            <a:ext cx="3044952" cy="347472"/>
+          </a:xfrm>
+          <a:prstGeom prst="rect">
+            <a:avLst/>
+          </a:prstGeom>
+          <a:noFill/>
+          <a:ln/>
+        </p:spPr>
+        <p:txBody>
+          <a:bodyPr wrap="square" lIns="0" tIns="0" rIns="0" bIns="0" rtlCol="0" anchor="ctr"/>
+          <a:lstStyle/>
+          <a:p>
+            <a:pPr algn="l" indent="0" marL="0">
+              <a:buNone/>
+            </a:pPr>
+            <a:r>
+              <a:rPr lang="en-US" sz="1550" b="1" dirty="0">
+                <a:solidFill>
+                  <a:srgbClr val="0F172A"/>
+                </a:solidFill>
+                <a:latin typeface="Arial" pitchFamily="34" charset="0"/>
+                <a:ea typeface="Arial" pitchFamily="34" charset="-122"/>
+                <a:cs typeface="Arial" pitchFamily="34" charset="-120"/>
+              </a:rPr>
+              <a:t>Four-eyes + scheduling</a:t>
+            </a:r>
+            <a:endParaRPr lang="en-US" sz="1550" dirty="0"/>
+          </a:p>
+        </p:txBody>
+      </p:sp>
+      <p:sp>
+        <p:nvSpPr>
+          <p:cNvPr id="33" name="Text 31"/>
+          <p:cNvSpPr/>
+          <p:nvPr/>
+        </p:nvSpPr>
+        <p:spPr>
+          <a:xfrm>
+            <a:off x="4535424" y="4754880"/>
+            <a:ext cx="3026664" cy="786384"/>
+          </a:xfrm>
+          <a:prstGeom prst="rect">
+            <a:avLst/>
+          </a:prstGeom>
+          <a:noFill/>
+          <a:ln/>
+        </p:spPr>
+        <p:txBody>
+          <a:bodyPr wrap="square" lIns="0" tIns="0" rIns="0" bIns="0" rtlCol="0" anchor="ctr"/>
+          <a:lstStyle/>
+          <a:p>
+            <a:pPr algn="l" indent="0" marL="0">
+              <a:lnSpc>
+                <a:spcPct val="113000"/>
+              </a:lnSpc>
+              <a:buNone/>
+            </a:pPr>
+            <a:r>
+              <a:rPr lang="en-US" sz="1150" dirty="0">
+                <a:solidFill>
+                  <a:srgbClr val="475569"/>
+                </a:solidFill>
+                <a:latin typeface="Arial" pitchFamily="34" charset="0"/>
+                <a:ea typeface="Arial" pitchFamily="34" charset="-122"/>
+                <a:cs typeface="Arial" pitchFamily="34" charset="-120"/>
+              </a:rPr>
+              <a:t>Owner-set dual approval, plus maintenance-window Apply that fires on a timer.</a:t>
+            </a:r>
+            <a:endParaRPr lang="en-US" sz="1150" dirty="0"/>
+          </a:p>
+        </p:txBody>
+      </p:sp>
+      <p:sp>
+        <p:nvSpPr>
+          <p:cNvPr id="34" name="Shape 32"/>
+          <p:cNvSpPr/>
+          <p:nvPr/>
+        </p:nvSpPr>
+        <p:spPr>
+          <a:xfrm>
+            <a:off x="4535424" y="5596128"/>
+            <a:ext cx="2990088" cy="0"/>
+          </a:xfrm>
+          <a:prstGeom prst="line">
+            <a:avLst/>
+          </a:prstGeom>
+          <a:noFill/>
+          <a:ln w="12700">
+            <a:solidFill>
+              <a:srgbClr val="E2E8F0"/>
+            </a:solidFill>
+            <a:prstDash val="solid"/>
+          </a:ln>
+        </p:spPr>
+      </p:sp>
+      <p:sp>
+        <p:nvSpPr>
+          <p:cNvPr id="35" name="Text 33"/>
+          <p:cNvSpPr/>
+          <p:nvPr/>
+        </p:nvSpPr>
+        <p:spPr>
+          <a:xfrm>
+            <a:off x="4535424" y="5650992"/>
+            <a:ext cx="3026664" cy="384048"/>
+          </a:xfrm>
+          <a:prstGeom prst="rect">
+            <a:avLst/>
+          </a:prstGeom>
+          <a:noFill/>
+          <a:ln/>
+        </p:spPr>
+        <p:txBody>
+          <a:bodyPr wrap="square" lIns="0" tIns="0" rIns="0" bIns="0" rtlCol="0" anchor="ctr"/>
+          <a:lstStyle/>
+          <a:p>
+            <a:pPr algn="l" indent="0" marL="0">
+              <a:lnSpc>
+                <a:spcPct val="105000"/>
+              </a:lnSpc>
+              <a:buNone/>
+            </a:pPr>
+            <a:r>
+              <a:rPr lang="en-US" sz="880" dirty="0">
+                <a:solidFill>
+                  <a:srgbClr val="64748B"/>
+                </a:solidFill>
+                <a:latin typeface="Courier New" pitchFamily="34" charset="0"/>
+                <a:ea typeface="Courier New" pitchFamily="34" charset="-122"/>
+                <a:cs typeface="Courier New" pitchFamily="34" charset="-120"/>
+              </a:rPr>
+              <a:t>setFourEyes · approveAction · scheduleApply</a:t>
+            </a:r>
+            <a:endParaRPr lang="en-US" sz="880" dirty="0"/>
+          </a:p>
+        </p:txBody>
+      </p:sp>
+      <p:sp>
+        <p:nvSpPr>
+          <p:cNvPr id="36" name="Shape 34"/>
+          <p:cNvSpPr/>
+          <p:nvPr/>
+        </p:nvSpPr>
+        <p:spPr>
+          <a:xfrm>
+            <a:off x="7918704" y="4151376"/>
+            <a:ext cx="3502152" cy="1956816"/>
+          </a:xfrm>
+          <a:prstGeom prst="rect">
+            <a:avLst/>
+          </a:prstGeom>
+          <a:solidFill>
+            <a:srgbClr val="FFFFFF"/>
+          </a:solidFill>
+          <a:ln w="12700">
+            <a:solidFill>
+              <a:srgbClr val="E2E8F0"/>
+            </a:solidFill>
+            <a:prstDash val="solid"/>
+          </a:ln>
+          <a:effectLst>
+            <a:outerShdw sx="100000" sy="100000" kx="0" ky="0" algn="bl" rotWithShape="0" blurRad="114300" dist="38100" dir="5400000">
+              <a:srgbClr val="0B1220">
+                <a:alpha val="16000"/>
+              </a:srgbClr>
+            </a:outerShdw>
+          </a:effectLst>
+        </p:spPr>
+      </p:sp>
+      <p:sp>
+        <p:nvSpPr>
+          <p:cNvPr id="37" name="Shape 35"/>
+          <p:cNvSpPr/>
+          <p:nvPr/>
+        </p:nvSpPr>
+        <p:spPr>
+          <a:xfrm>
+            <a:off x="7918704" y="4151376"/>
+            <a:ext cx="3502152" cy="82296"/>
+          </a:xfrm>
+          <a:prstGeom prst="rect">
+            <a:avLst/>
+          </a:prstGeom>
+          <a:solidFill>
+            <a:srgbClr val="22C55E"/>
+          </a:solidFill>
+          <a:ln/>
+        </p:spPr>
+      </p:sp>
+      <p:sp>
+        <p:nvSpPr>
+          <p:cNvPr id="38" name="Text 36"/>
+          <p:cNvSpPr/>
+          <p:nvPr/>
+        </p:nvSpPr>
+        <p:spPr>
+          <a:xfrm>
+            <a:off x="8174736" y="4370832"/>
+            <a:ext cx="3044952" cy="347472"/>
+          </a:xfrm>
+          <a:prstGeom prst="rect">
+            <a:avLst/>
+          </a:prstGeom>
+          <a:noFill/>
+          <a:ln/>
+        </p:spPr>
+        <p:txBody>
+          <a:bodyPr wrap="square" lIns="0" tIns="0" rIns="0" bIns="0" rtlCol="0" anchor="ctr"/>
+          <a:lstStyle/>
+          <a:p>
+            <a:pPr algn="l" indent="0" marL="0">
+              <a:buNone/>
+            </a:pPr>
+            <a:r>
+              <a:rPr lang="en-US" sz="1550" b="1" dirty="0">
+                <a:solidFill>
+                  <a:srgbClr val="0F172A"/>
+                </a:solidFill>
+                <a:latin typeface="Arial" pitchFamily="34" charset="0"/>
+                <a:ea typeface="Arial" pitchFamily="34" charset="-122"/>
+                <a:cs typeface="Arial" pitchFamily="34" charset="-120"/>
+              </a:rPr>
+              <a:t>Notifications</a:t>
+            </a:r>
+            <a:endParaRPr lang="en-US" sz="1550" dirty="0"/>
+          </a:p>
+        </p:txBody>
+      </p:sp>
+      <p:sp>
+        <p:nvSpPr>
+          <p:cNvPr id="39" name="Text 37"/>
+          <p:cNvSpPr/>
+          <p:nvPr/>
+        </p:nvSpPr>
+        <p:spPr>
+          <a:xfrm>
+            <a:off x="8174736" y="4754880"/>
+            <a:ext cx="3026664" cy="786384"/>
+          </a:xfrm>
+          <a:prstGeom prst="rect">
+            <a:avLst/>
+          </a:prstGeom>
+          <a:noFill/>
+          <a:ln/>
+        </p:spPr>
+        <p:txBody>
+          <a:bodyPr wrap="square" lIns="0" tIns="0" rIns="0" bIns="0" rtlCol="0" anchor="ctr"/>
+          <a:lstStyle/>
+          <a:p>
+            <a:pPr algn="l" indent="0" marL="0">
+              <a:lnSpc>
+                <a:spcPct val="113000"/>
+              </a:lnSpc>
+              <a:buNone/>
+            </a:pPr>
+            <a:r>
+              <a:rPr lang="en-US" sz="1150" dirty="0">
+                <a:solidFill>
+                  <a:srgbClr val="475569"/>
+                </a:solidFill>
+                <a:latin typeface="Arial" pitchFamily="34" charset="0"/>
+                <a:ea typeface="Arial" pitchFamily="34" charset="-122"/>
+                <a:cs typeface="Arial" pitchFamily="34" charset="-120"/>
+              </a:rPr>
+              <a:t>An in-app feed plus an owner-set, encrypted, SSRF-guarded webhook (Slack / structured JSON).</a:t>
+            </a:r>
+            <a:endParaRPr lang="en-US" sz="1150" dirty="0"/>
+          </a:p>
+        </p:txBody>
+      </p:sp>
+      <p:sp>
+        <p:nvSpPr>
+          <p:cNvPr id="40" name="Shape 38"/>
+          <p:cNvSpPr/>
+          <p:nvPr/>
+        </p:nvSpPr>
+        <p:spPr>
+          <a:xfrm>
+            <a:off x="8174736" y="5596128"/>
+            <a:ext cx="2990088" cy="0"/>
+          </a:xfrm>
+          <a:prstGeom prst="line">
+            <a:avLst/>
+          </a:prstGeom>
+          <a:noFill/>
+          <a:ln w="12700">
+            <a:solidFill>
+              <a:srgbClr val="E2E8F0"/>
+            </a:solidFill>
+            <a:prstDash val="solid"/>
+          </a:ln>
+        </p:spPr>
+      </p:sp>
+      <p:sp>
+        <p:nvSpPr>
+          <p:cNvPr id="41" name="Text 39"/>
+          <p:cNvSpPr/>
+          <p:nvPr/>
+        </p:nvSpPr>
+        <p:spPr>
+          <a:xfrm>
+            <a:off x="8174736" y="5650992"/>
+            <a:ext cx="3026664" cy="384048"/>
+          </a:xfrm>
+          <a:prstGeom prst="rect">
+            <a:avLst/>
+          </a:prstGeom>
+          <a:noFill/>
+          <a:ln/>
+        </p:spPr>
+        <p:txBody>
+          <a:bodyPr wrap="square" lIns="0" tIns="0" rIns="0" bIns="0" rtlCol="0" anchor="ctr"/>
+          <a:lstStyle/>
+          <a:p>
+            <a:pPr algn="l" indent="0" marL="0">
+              <a:lnSpc>
+                <a:spcPct val="105000"/>
+              </a:lnSpc>
+              <a:buNone/>
+            </a:pPr>
+            <a:r>
+              <a:rPr lang="en-US" sz="880" dirty="0">
+                <a:solidFill>
+                  <a:srgbClr val="64748B"/>
+                </a:solidFill>
+                <a:latin typeface="Courier New" pitchFamily="34" charset="0"/>
+                <a:ea typeface="Courier New" pitchFamily="34" charset="-122"/>
+                <a:cs typeface="Courier New" pitchFamily="34" charset="-120"/>
+              </a:rPr>
+              <a:t>setNotifyWebhook · testNotifyWebhook</a:t>
+            </a:r>
+            <a:endParaRPr lang="en-US" sz="880" dirty="0"/>
+          </a:p>
+        </p:txBody>
+      </p:sp>
+      <p:sp>
+        <p:nvSpPr>
+          <p:cNvPr id="42" name="Shape 40"/>
+          <p:cNvSpPr/>
+          <p:nvPr/>
+        </p:nvSpPr>
+        <p:spPr>
+          <a:xfrm>
+            <a:off x="640080" y="6419088"/>
+            <a:ext cx="10908792" cy="0"/>
+          </a:xfrm>
+          <a:prstGeom prst="line">
+            <a:avLst/>
+          </a:prstGeom>
+          <a:noFill/>
+          <a:ln w="12700">
+            <a:solidFill>
+              <a:srgbClr val="E2E8F0"/>
+            </a:solidFill>
+            <a:prstDash val="solid"/>
+          </a:ln>
+        </p:spPr>
+      </p:sp>
+      <p:sp>
+        <p:nvSpPr>
+          <p:cNvPr id="43" name="Text 41"/>
+          <p:cNvSpPr/>
+          <p:nvPr/>
+        </p:nvSpPr>
+        <p:spPr>
+          <a:xfrm>
+            <a:off x="640080" y="6455664"/>
+            <a:ext cx="7315200" cy="274320"/>
+          </a:xfrm>
+          <a:prstGeom prst="rect">
+            <a:avLst/>
+          </a:prstGeom>
+          <a:noFill/>
+          <a:ln/>
+        </p:spPr>
+        <p:txBody>
+          <a:bodyPr wrap="square" lIns="0" tIns="0" rIns="0" bIns="0" rtlCol="0" anchor="ctr"/>
+          <a:lstStyle/>
+          <a:p>
+            <a:pPr algn="l" indent="0" marL="0">
+              <a:buNone/>
+            </a:pPr>
+            <a:r>
+              <a:rPr lang="en-US" sz="950" b="1" dirty="0">
+                <a:solidFill>
+                  <a:srgbClr val="0F172A"/>
+                </a:solidFill>
+                <a:latin typeface="Arial" pitchFamily="34" charset="0"/>
+                <a:ea typeface="Arial" pitchFamily="34" charset="-122"/>
+                <a:cs typeface="Arial" pitchFamily="34" charset="-120"/>
+              </a:rPr>
+              <a:t>Glide</a:t>
+            </a:r>
+            <a:pPr algn="l" indent="0" marL="0">
+              <a:buNone/>
+            </a:pPr>
+            <a:r>
+              <a:rPr lang="en-US" sz="950" dirty="0">
+                <a:solidFill>
+                  <a:srgbClr val="64748B"/>
+                </a:solidFill>
+                <a:latin typeface="Arial" pitchFamily="34" charset="0"/>
+                <a:ea typeface="Arial" pitchFamily="34" charset="-122"/>
+                <a:cs typeface="Arial" pitchFamily="34" charset="-120"/>
+              </a:rPr>
+              <a:t xml:space="preserve">   Cloudflare onboarding agent</a:t>
+            </a:r>
+            <a:endParaRPr lang="en-US" sz="950" dirty="0"/>
+          </a:p>
+        </p:txBody>
+      </p:sp>
+      <p:sp>
+        <p:nvSpPr>
+          <p:cNvPr id="44" name="Text 42"/>
+          <p:cNvSpPr/>
+          <p:nvPr/>
+        </p:nvSpPr>
+        <p:spPr>
+          <a:xfrm>
+            <a:off x="9720072" y="6455664"/>
+            <a:ext cx="1828800" cy="274320"/>
+          </a:xfrm>
+          <a:prstGeom prst="rect">
+            <a:avLst/>
+          </a:prstGeom>
+          <a:noFill/>
+          <a:ln/>
+        </p:spPr>
+        <p:txBody>
+          <a:bodyPr wrap="square" lIns="0" tIns="0" rIns="0" bIns="0" rtlCol="0" anchor="ctr"/>
+          <a:lstStyle/>
+          <a:p>
+            <a:pPr algn="r" indent="0" marL="0">
+              <a:buNone/>
+            </a:pPr>
+            <a:r>
+              <a:rPr lang="en-US" sz="950" dirty="0">
+                <a:solidFill>
+                  <a:srgbClr val="64748B"/>
+                </a:solidFill>
+                <a:latin typeface="Arial" pitchFamily="34" charset="0"/>
+                <a:ea typeface="Arial" pitchFamily="34" charset="-122"/>
+                <a:cs typeface="Arial" pitchFamily="34" charset="-120"/>
+              </a:rPr>
+              <a:t>7 / 9</a:t>
+            </a:r>
+            <a:endParaRPr lang="en-US" sz="950" dirty="0"/>
+          </a:p>
+        </p:txBody>
+      </p:sp>
+    </p:spTree>
+  </p:cSld>
+  <p:clrMapOvr>
+    <a:masterClrMapping/>
+  </p:clrMapOvr>
+</p:sld>
+</file>
+
+<file path=ppt/slides/slide9.xml><?xml version="1.0" encoding="utf-8"?>
+<p:sld xmlns:a="http://schemas.openxmlformats.org/drawingml/2006/main" xmlns:r="http://schemas.openxmlformats.org/officeDocument/2006/relationships" xmlns:p="http://schemas.openxmlformats.org/presentationml/2006/main">
+  <p:cSld name="Slide 3">
+    <p:bg>
+      <p:bgPr>
+        <a:solidFill>
+          <a:srgbClr val="070B16"/>
+        </a:solidFill>
+      </p:bgPr>
+    </p:bg>
+    <p:spTree>
+      <p:nvGrpSpPr>
+        <p:cNvPr id="1" name=""/>
+        <p:cNvGrpSpPr/>
+        <p:nvPr/>
+      </p:nvGrpSpPr>
+      <p:grpSpPr>
+        <a:xfrm>
+          <a:off x="0" y="0"/>
+          <a:ext cx="0" cy="0"/>
+          <a:chOff x="0" y="0"/>
+          <a:chExt cx="0" cy="0"/>
+        </a:xfrm>
+      </p:grpSpPr>
+      <p:sp>
+        <p:nvSpPr>
+          <p:cNvPr id="2" name="Text 0"/>
+          <p:cNvSpPr/>
+          <p:nvPr/>
+        </p:nvSpPr>
+        <p:spPr>
+          <a:xfrm>
+            <a:off x="640080" y="502920"/>
+            <a:ext cx="7315200" cy="292608"/>
+          </a:xfrm>
+          <a:prstGeom prst="rect">
+            <a:avLst/>
+          </a:prstGeom>
+          <a:noFill/>
+          <a:ln/>
+        </p:spPr>
+        <p:txBody>
+          <a:bodyPr wrap="square" lIns="0" tIns="0" rIns="0" bIns="0" rtlCol="0" anchor="ctr"/>
+          <a:lstStyle/>
+          <a:p>
+            <a:pPr algn="l" indent="0" marL="0">
+              <a:buNone/>
+            </a:pPr>
+            <a:r>
+              <a:rPr lang="en-US" sz="1200" b="1" spc="300" kern="0" dirty="0">
+                <a:solidFill>
+                  <a:srgbClr val="F97316"/>
+                </a:solidFill>
+                <a:latin typeface="Arial" pitchFamily="34" charset="0"/>
+                <a:ea typeface="Arial" pitchFamily="34" charset="-122"/>
+                <a:cs typeface="Arial" pitchFamily="34" charset="-120"/>
+              </a:rPr>
+              <a:t>RETURN ON INVESTMENT</a:t>
+            </a:r>
+            <a:endParaRPr lang="en-US" sz="1200" dirty="0"/>
+          </a:p>
+        </p:txBody>
+      </p:sp>
+      <p:sp>
+        <p:nvSpPr>
+          <p:cNvPr id="3" name="Text 1"/>
+          <p:cNvSpPr/>
+          <p:nvPr/>
+        </p:nvSpPr>
+        <p:spPr>
+          <a:xfrm>
+            <a:off x="621792" y="777240"/>
+            <a:ext cx="10881360" cy="640080"/>
+          </a:xfrm>
+          <a:prstGeom prst="rect">
+            <a:avLst/>
+          </a:prstGeom>
+          <a:noFill/>
+          <a:ln/>
+        </p:spPr>
+        <p:txBody>
+          <a:bodyPr wrap="square" lIns="0" tIns="0" rIns="0" bIns="0" rtlCol="0" anchor="ctr"/>
+          <a:lstStyle/>
+          <a:p>
+            <a:pPr algn="l" indent="0" marL="0">
+              <a:buNone/>
+            </a:pPr>
+            <a:r>
+              <a:rPr lang="en-US" sz="3000" b="1" dirty="0">
+                <a:solidFill>
+                  <a:srgbClr val="FFFFFF"/>
+                </a:solidFill>
+                <a:latin typeface="Arial" pitchFamily="34" charset="0"/>
+                <a:ea typeface="Arial" pitchFamily="34" charset="-122"/>
+                <a:cs typeface="Arial" pitchFamily="34" charset="-120"/>
+              </a:rPr>
+              <a:t>Hours back on every onboarding.</a:t>
+            </a:r>
+            <a:endParaRPr lang="en-US" sz="3000" dirty="0"/>
+          </a:p>
+        </p:txBody>
+      </p:sp>
+      <p:sp>
+        <p:nvSpPr>
+          <p:cNvPr id="4" name="Text 2"/>
+          <p:cNvSpPr/>
+          <p:nvPr/>
+        </p:nvSpPr>
+        <p:spPr>
+          <a:xfrm>
+            <a:off x="640080" y="1481328"/>
+            <a:ext cx="10789920" cy="640080"/>
+          </a:xfrm>
+          <a:prstGeom prst="rect">
+            <a:avLst/>
+          </a:prstGeom>
+          <a:noFill/>
+          <a:ln/>
+        </p:spPr>
+        <p:txBody>
+          <a:bodyPr wrap="square" lIns="0" tIns="0" rIns="0" bIns="0" rtlCol="0" anchor="ctr"/>
+          <a:lstStyle/>
+          <a:p>
+            <a:pPr algn="l" indent="0" marL="0">
+              <a:lnSpc>
+                <a:spcPct val="118000"/>
+              </a:lnSpc>
+              <a:buNone/>
+            </a:pPr>
+            <a:r>
+              <a:rPr lang="en-US" sz="1450" dirty="0">
+                <a:solidFill>
+                  <a:srgbClr val="C7D2E4"/>
+                </a:solidFill>
+                <a:latin typeface="Arial" pitchFamily="34" charset="0"/>
+                <a:ea typeface="Arial" pitchFamily="34" charset="-122"/>
+                <a:cs typeface="Arial" pitchFamily="34" charset="-120"/>
+              </a:rPr>
+              <a:t>A ~40-hour manual onboarding — DNS, SSL, WAF, cache and Zero Trust across dashboards — drops to about 8 hours with Glide. Estimated at a $100/hr blended rate:</a:t>
+            </a:r>
+            <a:endParaRPr lang="en-US" sz="1450" dirty="0"/>
+          </a:p>
+        </p:txBody>
+      </p:sp>
+      <p:sp>
+        <p:nvSpPr>
+          <p:cNvPr id="5" name="Shape 3"/>
+          <p:cNvSpPr/>
+          <p:nvPr/>
+        </p:nvSpPr>
+        <p:spPr>
+          <a:xfrm>
+            <a:off x="640080" y="3070000"/>
+            <a:ext cx="2148840" cy="1500000"/>
+          </a:xfrm>
+          <a:prstGeom prst="roundRect">
+            <a:avLst>
+              <a:gd name="adj" fmla="val 10870"/>
+            </a:avLst>
+          </a:prstGeom>
+          <a:solidFill>
+            <a:srgbClr val="111A2E"/>
+          </a:solidFill>
+          <a:ln w="15875">
+            <a:solidFill>
+              <a:srgbClr val="1B2740"/>
+            </a:solidFill>
+            <a:prstDash val="solid"/>
+          </a:ln>
+          <a:effectLst>
+            <a:outerShdw sx="100000" sy="100000" kx="0" ky="0" algn="bl" rotWithShape="0" blurRad="127000" dist="38100" dir="5400000">
+              <a:srgbClr val="000000">
+                <a:alpha val="35000"/>
+              </a:srgbClr>
+            </a:outerShdw>
+          </a:effectLst>
+        </p:spPr>
+      </p:sp>
+      <p:sp>
+        <p:nvSpPr>
+          <p:cNvPr id="6" name="Text 4"/>
+          <p:cNvSpPr/>
+          <p:nvPr/>
+        </p:nvSpPr>
+        <p:spPr>
+          <a:xfrm>
+            <a:off x="731520" y="3070000"/>
+            <a:ext cx="1965960" cy="1500000"/>
+          </a:xfrm>
+          <a:prstGeom prst="rect">
+            <a:avLst/>
+          </a:prstGeom>
+          <a:noFill/>
+          <a:ln/>
+        </p:spPr>
+        <p:txBody>
+          <a:bodyPr wrap="square" lIns="0" tIns="0" rIns="0" bIns="0" rtlCol="0" anchor="ctr"/>
+          <a:lstStyle/>
+          <a:p>
+            <a:pPr algn="ctr" indent="0" marL="0">
+              <a:lnSpc>
+                <a:spcPct val="105000"/>
+              </a:lnSpc>
+              <a:buNone/>
+            </a:pPr>
+            <a:r>
+              <a:rPr lang="en-US" sz="3200" b="1" dirty="0">
+                <a:solidFill>
+                  <a:srgbClr val="C7D2E4"/>
+                </a:solidFill>
+                <a:latin typeface="Arial" pitchFamily="34" charset="0"/>
+                <a:ea typeface="Arial" pitchFamily="34" charset="-122"/>
+                <a:cs typeface="Arial" pitchFamily="34" charset="-120"/>
+              </a:rPr>
+              <a:t>~32 hrs</a:t>
+            </a:r>
+            <a:endParaRPr lang="en-US" sz="1350" dirty="0"/>
+          </a:p>
+          <a:p>
+            <a:pPr algn="ctr" indent="0" marL="0">
+              <a:lnSpc>
+                <a:spcPct val="105000"/>
+              </a:lnSpc>
+              <a:buNone/>
+            </a:pPr>
+            <a:r>
+              <a:rPr lang="en-US" sz="1150" dirty="0">
+                <a:solidFill>
+                  <a:srgbClr val="C7D2E4"/>
+                </a:solidFill>
+                <a:latin typeface="Arial" pitchFamily="34" charset="0"/>
+                <a:ea typeface="Arial" pitchFamily="34" charset="-122"/>
+                <a:cs typeface="Arial" pitchFamily="34" charset="-120"/>
+              </a:rPr>
+              <a:t>engineer-time saved</a:t>
+            </a:r>
+            <a:endParaRPr lang="en-US" sz="1350" dirty="0"/>
+          </a:p>
+        </p:txBody>
+      </p:sp>
+      <p:sp>
+        <p:nvSpPr>
+          <p:cNvPr id="8" name="Shape 6"/>
+          <p:cNvSpPr/>
+          <p:nvPr/>
+        </p:nvSpPr>
+        <p:spPr>
+          <a:xfrm>
+            <a:off x="3172968" y="3070000"/>
+            <a:ext cx="2331720" cy="1500000"/>
+          </a:xfrm>
+          <a:prstGeom prst="roundRect">
+            <a:avLst>
+              <a:gd name="adj" fmla="val 10870"/>
+            </a:avLst>
+          </a:prstGeom>
+          <a:solidFill>
+            <a:srgbClr val="241633"/>
+          </a:solidFill>
+          <a:ln w="15875">
+            <a:solidFill>
+              <a:srgbClr val="8B5CF6"/>
+            </a:solidFill>
+            <a:prstDash val="solid"/>
+          </a:ln>
+          <a:effectLst>
+            <a:outerShdw sx="100000" sy="100000" kx="0" ky="0" algn="bl" rotWithShape="0" blurRad="127000" dist="38100" dir="5400000">
+              <a:srgbClr val="000000">
+                <a:alpha val="35000"/>
+              </a:srgbClr>
+            </a:outerShdw>
+          </a:effectLst>
+        </p:spPr>
+      </p:sp>
+      <p:sp>
+        <p:nvSpPr>
+          <p:cNvPr id="9" name="Text 7"/>
+          <p:cNvSpPr/>
+          <p:nvPr/>
+        </p:nvSpPr>
+        <p:spPr>
+          <a:xfrm>
+            <a:off x="3264408" y="3070000"/>
+            <a:ext cx="2148840" cy="1500000"/>
+          </a:xfrm>
+          <a:prstGeom prst="rect">
+            <a:avLst/>
+          </a:prstGeom>
+          <a:noFill/>
+          <a:ln/>
+        </p:spPr>
+        <p:txBody>
+          <a:bodyPr wrap="square" lIns="0" tIns="0" rIns="0" bIns="0" rtlCol="0" anchor="ctr"/>
+          <a:lstStyle/>
+          <a:p>
+            <a:pPr algn="ctr" indent="0" marL="0">
+              <a:lnSpc>
+                <a:spcPct val="105000"/>
+              </a:lnSpc>
+              <a:buNone/>
+            </a:pPr>
+            <a:r>
+              <a:rPr lang="en-US" sz="3200" b="1" dirty="0">
+                <a:solidFill>
+                  <a:srgbClr val="FFFFFF"/>
+                </a:solidFill>
+                <a:latin typeface="Arial" pitchFamily="34" charset="0"/>
+                <a:ea typeface="Arial" pitchFamily="34" charset="-122"/>
+                <a:cs typeface="Arial" pitchFamily="34" charset="-120"/>
+              </a:rPr>
+              <a:t>$3,200</a:t>
+            </a:r>
+            <a:endParaRPr lang="en-US" sz="1350" dirty="0"/>
+          </a:p>
+          <a:p>
+            <a:pPr algn="ctr" indent="0" marL="0">
+              <a:lnSpc>
+                <a:spcPct val="105000"/>
+              </a:lnSpc>
+              <a:buNone/>
+            </a:pPr>
+            <a:r>
+              <a:rPr lang="en-US" sz="1150" dirty="0">
+                <a:solidFill>
+                  <a:srgbClr val="FFFFFF"/>
+                </a:solidFill>
+                <a:latin typeface="Arial" pitchFamily="34" charset="0"/>
+                <a:ea typeface="Arial" pitchFamily="34" charset="-122"/>
+                <a:cs typeface="Arial" pitchFamily="34" charset="-120"/>
+              </a:rPr>
+              <a:t>cost saved · $100/hr</a:t>
+            </a:r>
+            <a:endParaRPr lang="en-US" sz="1350" dirty="0"/>
+          </a:p>
+        </p:txBody>
+      </p:sp>
+      <p:sp>
+        <p:nvSpPr>
+          <p:cNvPr id="11" name="Shape 9"/>
+          <p:cNvSpPr/>
+          <p:nvPr/>
+        </p:nvSpPr>
+        <p:spPr>
+          <a:xfrm>
+            <a:off x="5888736" y="3070000"/>
+            <a:ext cx="2331720" cy="1500000"/>
+          </a:xfrm>
+          <a:prstGeom prst="roundRect">
+            <a:avLst>
+              <a:gd name="adj" fmla="val 10870"/>
+            </a:avLst>
+          </a:prstGeom>
+          <a:solidFill>
+            <a:srgbClr val="3A1E0B"/>
+          </a:solidFill>
+          <a:ln w="15875">
+            <a:solidFill>
+              <a:srgbClr val="F97316"/>
+            </a:solidFill>
+            <a:prstDash val="solid"/>
+          </a:ln>
+          <a:effectLst>
+            <a:outerShdw sx="100000" sy="100000" kx="0" ky="0" algn="bl" rotWithShape="0" blurRad="127000" dist="38100" dir="5400000">
+              <a:srgbClr val="000000">
+                <a:alpha val="35000"/>
+              </a:srgbClr>
+            </a:outerShdw>
+          </a:effectLst>
+        </p:spPr>
+      </p:sp>
+      <p:sp>
+        <p:nvSpPr>
+          <p:cNvPr id="12" name="Text 10"/>
+          <p:cNvSpPr/>
+          <p:nvPr/>
+        </p:nvSpPr>
+        <p:spPr>
+          <a:xfrm>
+            <a:off x="5980176" y="3070000"/>
+            <a:ext cx="2148840" cy="1500000"/>
+          </a:xfrm>
+          <a:prstGeom prst="rect">
+            <a:avLst/>
+          </a:prstGeom>
+          <a:noFill/>
+          <a:ln/>
+        </p:spPr>
+        <p:txBody>
+          <a:bodyPr wrap="square" lIns="0" tIns="0" rIns="0" bIns="0" rtlCol="0" anchor="ctr"/>
+          <a:lstStyle/>
+          <a:p>
+            <a:pPr algn="ctr" indent="0" marL="0">
+              <a:lnSpc>
+                <a:spcPct val="105000"/>
+              </a:lnSpc>
+              <a:buNone/>
+            </a:pPr>
+            <a:r>
+              <a:rPr lang="en-US" sz="3200" b="1" dirty="0">
+                <a:solidFill>
+                  <a:srgbClr val="FBBF24"/>
+                </a:solidFill>
+                <a:latin typeface="Arial" pitchFamily="34" charset="0"/>
+                <a:ea typeface="Arial" pitchFamily="34" charset="-122"/>
+                <a:cs typeface="Arial" pitchFamily="34" charset="-120"/>
+              </a:rPr>
+              <a:t>~$160K</a:t>
+            </a:r>
+            <a:endParaRPr lang="en-US" sz="1350" dirty="0"/>
+          </a:p>
+          <a:p>
+            <a:pPr algn="ctr" indent="0" marL="0">
+              <a:lnSpc>
+                <a:spcPct val="105000"/>
+              </a:lnSpc>
+              <a:buNone/>
+            </a:pPr>
+            <a:r>
+              <a:rPr lang="en-US" sz="1150" dirty="0">
+                <a:solidFill>
+                  <a:srgbClr val="FBBF24"/>
+                </a:solidFill>
+                <a:latin typeface="Arial" pitchFamily="34" charset="0"/>
+                <a:ea typeface="Arial" pitchFamily="34" charset="-122"/>
+                <a:cs typeface="Arial" pitchFamily="34" charset="-120"/>
+              </a:rPr>
+              <a:t>saved per year (~50 runs)</a:t>
+            </a:r>
+            <a:endParaRPr lang="en-US" sz="1350" dirty="0"/>
+          </a:p>
+        </p:txBody>
+      </p:sp>
+      <p:sp>
+        <p:nvSpPr>
+          <p:cNvPr id="14" name="Shape 12"/>
+          <p:cNvSpPr/>
+          <p:nvPr/>
+        </p:nvSpPr>
+        <p:spPr>
+          <a:xfrm>
+            <a:off x="8604504" y="3070000"/>
+            <a:ext cx="3063240" cy="1500000"/>
+          </a:xfrm>
+          <a:prstGeom prst="roundRect">
+            <a:avLst>
+              <a:gd name="adj" fmla="val 10870"/>
+            </a:avLst>
+          </a:prstGeom>
+          <a:solidFill>
+            <a:srgbClr val="F97316"/>
+          </a:solidFill>
+          <a:ln/>
+          <a:effectLst>
+            <a:outerShdw sx="100000" sy="100000" kx="0" ky="0" algn="bl" rotWithShape="0" blurRad="127000" dist="38100" dir="5400000">
+              <a:srgbClr val="000000">
+                <a:alpha val="35000"/>
+              </a:srgbClr>
+            </a:outerShdw>
+          </a:effectLst>
+        </p:spPr>
+      </p:sp>
+      <p:sp>
+        <p:nvSpPr>
+          <p:cNvPr id="15" name="Text 13"/>
+          <p:cNvSpPr/>
+          <p:nvPr/>
+        </p:nvSpPr>
+        <p:spPr>
+          <a:xfrm>
+            <a:off x="8695944" y="3070000"/>
+            <a:ext cx="2880360" cy="1500000"/>
+          </a:xfrm>
+          <a:prstGeom prst="rect">
+            <a:avLst/>
+          </a:prstGeom>
+          <a:noFill/>
+          <a:ln/>
+        </p:spPr>
+        <p:txBody>
+          <a:bodyPr wrap="square" lIns="0" tIns="0" rIns="0" bIns="0" rtlCol="0" anchor="ctr"/>
+          <a:lstStyle/>
+          <a:p>
+            <a:pPr algn="ctr" indent="0" marL="0">
+              <a:lnSpc>
+                <a:spcPct val="105000"/>
+              </a:lnSpc>
+              <a:buNone/>
+            </a:pPr>
+            <a:r>
+              <a:rPr lang="en-US" sz="3200" b="1" dirty="0">
+                <a:solidFill>
+                  <a:srgbClr val="070B16"/>
+                </a:solidFill>
+                <a:latin typeface="Arial" pitchFamily="34" charset="0"/>
+                <a:ea typeface="Arial" pitchFamily="34" charset="-122"/>
+                <a:cs typeface="Arial" pitchFamily="34" charset="-120"/>
+              </a:rPr>
+              <a:t>0</a:t>
+            </a:r>
+            <a:endParaRPr lang="en-US" sz="1350" dirty="0"/>
+          </a:p>
+          <a:p>
+            <a:pPr algn="ctr" indent="0" marL="0">
+              <a:lnSpc>
+                <a:spcPct val="105000"/>
+              </a:lnSpc>
+              <a:buNone/>
+            </a:pPr>
+            <a:r>
+              <a:rPr lang="en-US" sz="1150" dirty="0">
+                <a:solidFill>
+                  <a:srgbClr val="070B16"/>
+                </a:solidFill>
+                <a:latin typeface="Arial" pitchFamily="34" charset="0"/>
+                <a:ea typeface="Arial" pitchFamily="34" charset="-122"/>
+                <a:cs typeface="Arial" pitchFamily="34" charset="-120"/>
+              </a:rPr>
+              <a:t>blind writes to prod</a:t>
+            </a:r>
+            <a:endParaRPr lang="en-US" sz="1350" dirty="0"/>
+          </a:p>
+        </p:txBody>
+      </p:sp>
+      <p:sp>
+        <p:nvSpPr>
+          <p:cNvPr id="35" name="Shape 33"/>
+          <p:cNvSpPr/>
+          <p:nvPr/>
+        </p:nvSpPr>
+        <p:spPr>
+          <a:xfrm>
+            <a:off x="640080" y="6419088"/>
+            <a:ext cx="10908792" cy="0"/>
+          </a:xfrm>
+          <a:prstGeom prst="line">
+            <a:avLst/>
+          </a:prstGeom>
+          <a:noFill/>
+          <a:ln w="12700">
+            <a:solidFill>
+              <a:srgbClr val="1B2740"/>
+            </a:solidFill>
+            <a:prstDash val="solid"/>
+          </a:ln>
+        </p:spPr>
+      </p:sp>
+      <p:sp>
+        <p:nvSpPr>
+          <p:cNvPr id="36" name="Text 34"/>
+          <p:cNvSpPr/>
+          <p:nvPr/>
+        </p:nvSpPr>
+        <p:spPr>
+          <a:xfrm>
+            <a:off x="640080" y="6455664"/>
+            <a:ext cx="7315200" cy="274320"/>
+          </a:xfrm>
+          <a:prstGeom prst="rect">
+            <a:avLst/>
+          </a:prstGeom>
+          <a:noFill/>
+          <a:ln/>
+        </p:spPr>
+        <p:txBody>
+          <a:bodyPr wrap="square" lIns="0" tIns="0" rIns="0" bIns="0" rtlCol="0" anchor="ctr"/>
+          <a:lstStyle/>
+          <a:p>
+            <a:pPr algn="l" indent="0" marL="0">
+              <a:buNone/>
+            </a:pPr>
+            <a:r>
+              <a:rPr lang="en-US" sz="950" b="1" dirty="0">
+                <a:solidFill>
+                  <a:srgbClr val="FFFFFF"/>
+                </a:solidFill>
+                <a:latin typeface="Arial" pitchFamily="34" charset="0"/>
+                <a:ea typeface="Arial" pitchFamily="34" charset="-122"/>
+                <a:cs typeface="Arial" pitchFamily="34" charset="-120"/>
+              </a:rPr>
+              <a:t>Glide</a:t>
+            </a:r>
+            <a:pPr algn="l" indent="0" marL="0">
+              <a:buNone/>
+            </a:pPr>
+            <a:r>
+              <a:rPr lang="en-US" sz="950" dirty="0">
+                <a:solidFill>
+                  <a:srgbClr val="94A3B8"/>
+                </a:solidFill>
+                <a:latin typeface="Arial" pitchFamily="34" charset="0"/>
+                <a:ea typeface="Arial" pitchFamily="34" charset="-122"/>
+                <a:cs typeface="Arial" pitchFamily="34" charset="-120"/>
+              </a:rPr>
+              <a:t xml:space="preserve">   Cloudflare onboarding agent</a:t>
+            </a:r>
+            <a:endParaRPr lang="en-US" sz="950" dirty="0"/>
+          </a:p>
+        </p:txBody>
+      </p:sp>
+      <p:sp>
+        <p:nvSpPr>
+          <p:cNvPr id="37" name="Text 35"/>
+          <p:cNvSpPr/>
+          <p:nvPr/>
+        </p:nvSpPr>
+        <p:spPr>
+          <a:xfrm>
+            <a:off x="9720072" y="6455664"/>
+            <a:ext cx="1828800" cy="274320"/>
+          </a:xfrm>
+          <a:prstGeom prst="rect">
+            <a:avLst/>
+          </a:prstGeom>
+          <a:noFill/>
+          <a:ln/>
+        </p:spPr>
+        <p:txBody>
+          <a:bodyPr wrap="square" lIns="0" tIns="0" rIns="0" bIns="0" rtlCol="0" anchor="ctr"/>
+          <a:lstStyle/>
+          <a:p>
+            <a:pPr algn="r" indent="0" marL="0">
+              <a:buNone/>
+            </a:pPr>
+            <a:r>
+              <a:rPr lang="en-US" sz="950" dirty="0">
+                <a:solidFill>
+                  <a:srgbClr val="94A3B8"/>
+                </a:solidFill>
+                <a:latin typeface="Arial" pitchFamily="34" charset="0"/>
+                <a:ea typeface="Arial" pitchFamily="34" charset="-122"/>
+                <a:cs typeface="Arial" pitchFamily="34" charset="-120"/>
+              </a:rPr>
+              <a:t>8 / 9</a:t>
             </a:r>
             <a:endParaRPr lang="en-US" sz="950" dirty="0"/>
           </a:p>

</xml_diff>